<commit_message>
feat: ship v1.1 what-if, history chart and updated jury guide
</commit_message>
<xml_diff>
--- a/release/jury/Neftekod_Presentation.pptx
+++ b/release/jury/Neftekod_Presentation.pptx
@@ -2,24 +2,26 @@
 <file path=ppt/presentation.xml><?xml version="1.0" encoding="utf-8"?>
 <p:presentation xmlns:p="http://schemas.openxmlformats.org/presentationml/2006/main">
   <p:sldMasterIdLst>
-    <p:sldMasterId xmlns:r="http://schemas.openxmlformats.org/officeDocument/2006/relationships" id="2147483648" r:id="Ra8395b6f599246c7"/>
+    <p:sldMasterId xmlns:r="http://schemas.openxmlformats.org/officeDocument/2006/relationships" id="2147483648" r:id="Rca887fd86bf8400c"/>
   </p:sldMasterIdLst>
   <p:notesMasterIdLst>
-    <p:notesMasterId xmlns:r="http://schemas.openxmlformats.org/officeDocument/2006/relationships" r:id="Rc7408ea3005d4401"/>
+    <p:notesMasterId xmlns:r="http://schemas.openxmlformats.org/officeDocument/2006/relationships" r:id="R4e88f30ae1004dcc"/>
   </p:notesMasterIdLst>
   <p:sldIdLst>
-    <p:sldId xmlns:r="http://schemas.openxmlformats.org/officeDocument/2006/relationships" id="256" r:id="R6185a02e20354338"/>
-    <p:sldId xmlns:r="http://schemas.openxmlformats.org/officeDocument/2006/relationships" id="257" r:id="Rf02603c8f1854b83"/>
-    <p:sldId xmlns:r="http://schemas.openxmlformats.org/officeDocument/2006/relationships" id="258" r:id="R7a3fdeb8f4824965"/>
-    <p:sldId xmlns:r="http://schemas.openxmlformats.org/officeDocument/2006/relationships" id="259" r:id="R9c278a1f20224f28"/>
-    <p:sldId xmlns:r="http://schemas.openxmlformats.org/officeDocument/2006/relationships" id="260" r:id="Rab8791de154841b2"/>
-    <p:sldId xmlns:r="http://schemas.openxmlformats.org/officeDocument/2006/relationships" id="261" r:id="Rbf53de69fa9a4f57"/>
-    <p:sldId xmlns:r="http://schemas.openxmlformats.org/officeDocument/2006/relationships" id="262" r:id="Rf6471f5f950643cd"/>
-    <p:sldId xmlns:r="http://schemas.openxmlformats.org/officeDocument/2006/relationships" id="263" r:id="R3d3ecf14ffdc4815"/>
-    <p:sldId xmlns:r="http://schemas.openxmlformats.org/officeDocument/2006/relationships" id="264" r:id="Re31dcf3c293e4a36"/>
-    <p:sldId xmlns:r="http://schemas.openxmlformats.org/officeDocument/2006/relationships" id="265" r:id="R1663485984824198"/>
-    <p:sldId xmlns:r="http://schemas.openxmlformats.org/officeDocument/2006/relationships" id="266" r:id="R5c851d36a2654f49"/>
-    <p:sldId xmlns:r="http://schemas.openxmlformats.org/officeDocument/2006/relationships" id="267" r:id="Ra3f08ffd59ae44a7"/>
+    <p:sldId xmlns:r="http://schemas.openxmlformats.org/officeDocument/2006/relationships" id="256" r:id="R01bf21af1f2041ab"/>
+    <p:sldId xmlns:r="http://schemas.openxmlformats.org/officeDocument/2006/relationships" id="257" r:id="Rfa7295286cca419b"/>
+    <p:sldId xmlns:r="http://schemas.openxmlformats.org/officeDocument/2006/relationships" id="258" r:id="Rbd4d25faa11442b2"/>
+    <p:sldId xmlns:r="http://schemas.openxmlformats.org/officeDocument/2006/relationships" id="259" r:id="R4edb9cdb26e74560"/>
+    <p:sldId xmlns:r="http://schemas.openxmlformats.org/officeDocument/2006/relationships" id="260" r:id="Re193551ecab749e9"/>
+    <p:sldId xmlns:r="http://schemas.openxmlformats.org/officeDocument/2006/relationships" id="261" r:id="R22d692ab0c774ea1"/>
+    <p:sldId xmlns:r="http://schemas.openxmlformats.org/officeDocument/2006/relationships" id="262" r:id="Rc6c26994489948fa"/>
+    <p:sldId xmlns:r="http://schemas.openxmlformats.org/officeDocument/2006/relationships" id="263" r:id="Ra3642dfdfdda4cb4"/>
+    <p:sldId xmlns:r="http://schemas.openxmlformats.org/officeDocument/2006/relationships" id="264" r:id="Rd24430b8d1d24f21"/>
+    <p:sldId xmlns:r="http://schemas.openxmlformats.org/officeDocument/2006/relationships" id="265" r:id="Rb3fc8e7ee7f74a62"/>
+    <p:sldId xmlns:r="http://schemas.openxmlformats.org/officeDocument/2006/relationships" id="266" r:id="R86936ad56fad4c63"/>
+    <p:sldId xmlns:r="http://schemas.openxmlformats.org/officeDocument/2006/relationships" id="267" r:id="R8c8d753d87bb4dba"/>
+    <p:sldId xmlns:r="http://schemas.openxmlformats.org/officeDocument/2006/relationships" id="268" r:id="R373c517ed6264a83"/>
+    <p:sldId xmlns:r="http://schemas.openxmlformats.org/officeDocument/2006/relationships" id="269" r:id="R364b8d7a6b494205"/>
   </p:sldIdLst>
   <p:sldSz cx="12192000" cy="6858000"/>
   <p:notesSz cx="6858000" cy="9144000"/>
@@ -463,7 +465,7 @@
           </a:p>
           <a:p xmlns:a="http://schemas.openxmlformats.org/drawingml/2006/main">
             <a:r>
-              <a:t>Версия: финальная поставка 22.09.2026, dev 88e317e + рабочие изменения.</a:t>
+              <a:t>Версия: финальная поставка 22.09.2026, выпуск v1.1.0.</a:t>
             </a:r>
           </a:p>
           <a:p xmlns:a="http://schemas.openxmlformats.org/drawingml/2006/main">
@@ -558,7 +560,7 @@
           </a:p>
           <a:p xmlns:a="http://schemas.openxmlformats.org/drawingml/2006/main">
             <a:r>
-              <a:t>Версия: финальная поставка 22.09.2026, dev 88e317e + рабочие изменения.</a:t>
+              <a:t>Версия: финальная поставка 22.09.2026, выпуск v1.1.0.</a:t>
             </a:r>
           </a:p>
           <a:p xmlns:a="http://schemas.openxmlformats.org/drawingml/2006/main">
@@ -653,7 +655,7 @@
           </a:p>
           <a:p xmlns:a="http://schemas.openxmlformats.org/drawingml/2006/main">
             <a:r>
-              <a:t>Версия: финальная поставка 22.09.2026, dev 88e317e + рабочие изменения.</a:t>
+              <a:t>Версия: финальная поставка 22.09.2026, выпуск v1.1.0.</a:t>
             </a:r>
           </a:p>
           <a:p xmlns:a="http://schemas.openxmlformats.org/drawingml/2006/main">
@@ -738,6 +740,196 @@
           <a:lstStyle xmlns:a="http://schemas.openxmlformats.org/drawingml/2006/main"/>
           <a:p xmlns:a="http://schemas.openxmlformats.org/drawingml/2006/main">
             <a:r>
+              <a:t>Файлы preset неизменны. Пустое качество — неизвестное. Недостаточные запасы дают отказ. В Повышенной сере измените серу A 6→1 и upper 7→2. Затем сбросьте и пересчитайте. JSON-экспорт содержит synthetic_scenario. Реальные уставки отключены.</a:t>
+            </a:r>
+          </a:p>
+          <a:p xmlns:a="http://schemas.openxmlformats.org/drawingml/2006/main">
+            <a:r>
+              <a:t/>
+            </a:r>
+          </a:p>
+          <a:p xmlns:a="http://schemas.openxmlformats.org/drawingml/2006/main">
+            <a:r>
+              <a:t>Версия: финальная поставка 22.09.2026, выпуск v1.1.0.</a:t>
+            </a:r>
+          </a:p>
+          <a:p xmlns:a="http://schemas.openxmlformats.org/drawingml/2006/main">
+            <a:r>
+              <a:t>Источники проекта:</a:t>
+            </a:r>
+          </a:p>
+          <a:p xmlns:a="http://schemas.openxmlformats.org/drawingml/2006/main">
+            <a:r>
+              <a:t>D:/ML/hakneft/HackathonPetrolCode/release/DEMO_SCRIPT.md</a:t>
+            </a:r>
+          </a:p>
+          <a:p xmlns:a="http://schemas.openxmlformats.org/drawingml/2006/main">
+            <a:r>
+              <a:t>D:/ML/hakneft/HackathonPetrolCode/source/ui_what_if.py</a:t>
+            </a:r>
+          </a:p>
+        </p:txBody>
+      </p:sp>
+      <p:sp>
+        <p:nvSpPr>
+          <p:cNvPr id="4" name="Slide Number Placeholder 3"/>
+          <p:cNvSpPr>
+            <a:spLocks xmlns:a="http://schemas.openxmlformats.org/drawingml/2006/main" noGrp="1"/>
+          </p:cNvSpPr>
+          <p:nvPr>
+            <p:ph type="sldNum" idx="5"/>
+          </p:nvPr>
+        </p:nvSpPr>
+        <p:spPr/>
+        <p:txBody>
+          <a:bodyPr xmlns:a="http://schemas.openxmlformats.org/drawingml/2006/main"/>
+          <a:lstStyle xmlns:a="http://schemas.openxmlformats.org/drawingml/2006/main"/>
+          <a:p xmlns:a="http://schemas.openxmlformats.org/drawingml/2006/main"/>
+        </p:txBody>
+      </p:sp>
+    </p:spTree>
+  </p:cSld>
+  <p:clrMapOvr>
+    <a:masterClrMapping xmlns:a="http://schemas.openxmlformats.org/drawingml/2006/main"/>
+  </p:clrMapOvr>
+</p:notes>
+</file>
+
+<file path=ppt/notesSlides/notesSlide13.xml><?xml version="1.0" encoding="utf-8"?>
+<p:notes xmlns:p="http://schemas.openxmlformats.org/presentationml/2006/main">
+  <p:cSld>
+    <p:spTree>
+      <p:nvGrpSpPr>
+        <p:cNvPr id="1" name=""/>
+        <p:cNvGrpSpPr/>
+        <p:nvPr/>
+      </p:nvGrpSpPr>
+      <p:grpSpPr>
+        <a:xfrm xmlns:a="http://schemas.openxmlformats.org/drawingml/2006/main"/>
+      </p:grpSpPr>
+      <p:sp>
+        <p:nvSpPr>
+          <p:cNvPr id="2" name="Slide Image Placeholder 1"/>
+          <p:cNvSpPr>
+            <a:spLocks xmlns:a="http://schemas.openxmlformats.org/drawingml/2006/main" noGrp="1"/>
+          </p:cNvSpPr>
+          <p:nvPr>
+            <p:ph type="sldImg" idx="0"/>
+          </p:nvPr>
+        </p:nvSpPr>
+        <p:spPr/>
+      </p:sp>
+      <p:sp>
+        <p:nvSpPr>
+          <p:cNvPr id="3" name="Notes Placeholder 2"/>
+          <p:cNvSpPr>
+            <a:spLocks xmlns:a="http://schemas.openxmlformats.org/drawingml/2006/main" noGrp="1"/>
+          </p:cNvSpPr>
+          <p:nvPr>
+            <p:ph type="body" idx="1"/>
+          </p:nvPr>
+        </p:nvSpPr>
+        <p:spPr/>
+        <p:txBody>
+          <a:bodyPr xmlns:a="http://schemas.openxmlformats.org/drawingml/2006/main"/>
+          <a:lstStyle xmlns:a="http://schemas.openxmlformats.org/drawingml/2006/main"/>
+          <a:p xmlns:a="http://schemas.openxmlformats.org/drawingml/2006/main">
+            <a:r>
+              <a:t>Каждая точка показывает прогноз на as_of + 60 минут; это не измеренный факт. Пропуски остаются разрывами. Наведение раскрывает точные значения. Исходные 12:00 и 13:00 дают целевые 13:00 и 14:00. Прогресс, отмена и JSON-экспорт сохранены.</a:t>
+            </a:r>
+          </a:p>
+          <a:p xmlns:a="http://schemas.openxmlformats.org/drawingml/2006/main">
+            <a:r>
+              <a:t/>
+            </a:r>
+          </a:p>
+          <a:p xmlns:a="http://schemas.openxmlformats.org/drawingml/2006/main">
+            <a:r>
+              <a:t>Версия: финальная поставка 22.09.2026, выпуск v1.1.0.</a:t>
+            </a:r>
+          </a:p>
+          <a:p xmlns:a="http://schemas.openxmlformats.org/drawingml/2006/main">
+            <a:r>
+              <a:t>Источники проекта:</a:t>
+            </a:r>
+          </a:p>
+          <a:p xmlns:a="http://schemas.openxmlformats.org/drawingml/2006/main">
+            <a:r>
+              <a:t>D:/ML/hakneft/HackathonPetrolCode/release/DEMO_SCRIPT.md</a:t>
+            </a:r>
+          </a:p>
+          <a:p xmlns:a="http://schemas.openxmlformats.org/drawingml/2006/main">
+            <a:r>
+              <a:t>D:/ML/hakneft/HackathonPetrolCode/source/ui_charts.py</a:t>
+            </a:r>
+          </a:p>
+        </p:txBody>
+      </p:sp>
+      <p:sp>
+        <p:nvSpPr>
+          <p:cNvPr id="4" name="Slide Number Placeholder 3"/>
+          <p:cNvSpPr>
+            <a:spLocks xmlns:a="http://schemas.openxmlformats.org/drawingml/2006/main" noGrp="1"/>
+          </p:cNvSpPr>
+          <p:nvPr>
+            <p:ph type="sldNum" idx="5"/>
+          </p:nvPr>
+        </p:nvSpPr>
+        <p:spPr/>
+        <p:txBody>
+          <a:bodyPr xmlns:a="http://schemas.openxmlformats.org/drawingml/2006/main"/>
+          <a:lstStyle xmlns:a="http://schemas.openxmlformats.org/drawingml/2006/main"/>
+          <a:p xmlns:a="http://schemas.openxmlformats.org/drawingml/2006/main"/>
+        </p:txBody>
+      </p:sp>
+    </p:spTree>
+  </p:cSld>
+  <p:clrMapOvr>
+    <a:masterClrMapping xmlns:a="http://schemas.openxmlformats.org/drawingml/2006/main"/>
+  </p:clrMapOvr>
+</p:notes>
+</file>
+
+<file path=ppt/notesSlides/notesSlide14.xml><?xml version="1.0" encoding="utf-8"?>
+<p:notes xmlns:p="http://schemas.openxmlformats.org/presentationml/2006/main">
+  <p:cSld>
+    <p:spTree>
+      <p:nvGrpSpPr>
+        <p:cNvPr id="1" name=""/>
+        <p:cNvGrpSpPr/>
+        <p:nvPr/>
+      </p:nvGrpSpPr>
+      <p:grpSpPr>
+        <a:xfrm xmlns:a="http://schemas.openxmlformats.org/drawingml/2006/main"/>
+      </p:grpSpPr>
+      <p:sp>
+        <p:nvSpPr>
+          <p:cNvPr id="2" name="Slide Image Placeholder 1"/>
+          <p:cNvSpPr>
+            <a:spLocks xmlns:a="http://schemas.openxmlformats.org/drawingml/2006/main" noGrp="1"/>
+          </p:cNvSpPr>
+          <p:nvPr>
+            <p:ph type="sldImg" idx="0"/>
+          </p:nvPr>
+        </p:nvSpPr>
+        <p:spPr/>
+      </p:sp>
+      <p:sp>
+        <p:nvSpPr>
+          <p:cNvPr id="3" name="Notes Placeholder 2"/>
+          <p:cNvSpPr>
+            <a:spLocks xmlns:a="http://schemas.openxmlformats.org/drawingml/2006/main" noGrp="1"/>
+          </p:cNvSpPr>
+          <p:nvPr>
+            <p:ph type="body" idx="1"/>
+          </p:nvPr>
+        </p:nvSpPr>
+        <p:spPr/>
+        <p:txBody>
+          <a:bodyPr xmlns:a="http://schemas.openxmlformats.org/drawingml/2006/main"/>
+          <a:lstStyle xmlns:a="http://schemas.openxmlformats.org/drawingml/2006/main"/>
+          <a:p xmlns:a="http://schemas.openxmlformats.org/drawingml/2006/main">
+            <a:r>
               <a:t>Для промышленного внедрения нужны инженерные диапазоны, карта потоков и задержек, валидация действий и надёжности, экономические данные. Это следующий этап, не скрытая возможность поставки.</a:t>
             </a:r>
           </a:p>
@@ -748,7 +940,7 @@
           </a:p>
           <a:p xmlns:a="http://schemas.openxmlformats.org/drawingml/2006/main">
             <a:r>
-              <a:t>Версия: финальная поставка 22.09.2026, dev 88e317e + рабочие изменения.</a:t>
+              <a:t>Версия: финальная поставка 22.09.2026, выпуск v1.1.0.</a:t>
             </a:r>
           </a:p>
           <a:p xmlns:a="http://schemas.openxmlformats.org/drawingml/2006/main">
@@ -843,7 +1035,7 @@
           </a:p>
           <a:p xmlns:a="http://schemas.openxmlformats.org/drawingml/2006/main">
             <a:r>
-              <a:t>Версия: финальная поставка 22.09.2026, dev 88e317e + рабочие изменения.</a:t>
+              <a:t>Версия: финальная поставка 22.09.2026, выпуск v1.1.0.</a:t>
             </a:r>
           </a:p>
           <a:p xmlns:a="http://schemas.openxmlformats.org/drawingml/2006/main">
@@ -938,7 +1130,7 @@
           </a:p>
           <a:p xmlns:a="http://schemas.openxmlformats.org/drawingml/2006/main">
             <a:r>
-              <a:t>Версия: финальная поставка 22.09.2026, dev 88e317e + рабочие изменения.</a:t>
+              <a:t>Версия: финальная поставка 22.09.2026, выпуск v1.1.0.</a:t>
             </a:r>
           </a:p>
           <a:p xmlns:a="http://schemas.openxmlformats.org/drawingml/2006/main">
@@ -1038,7 +1230,7 @@
           </a:p>
           <a:p xmlns:a="http://schemas.openxmlformats.org/drawingml/2006/main">
             <a:r>
-              <a:t>Версия: финальная поставка 22.09.2026, dev 88e317e + рабочие изменения.</a:t>
+              <a:t>Версия: финальная поставка 22.09.2026, выпуск v1.1.0.</a:t>
             </a:r>
           </a:p>
           <a:p xmlns:a="http://schemas.openxmlformats.org/drawingml/2006/main">
@@ -1138,7 +1330,7 @@
           </a:p>
           <a:p xmlns:a="http://schemas.openxmlformats.org/drawingml/2006/main">
             <a:r>
-              <a:t>Версия: финальная поставка 22.09.2026, dev 88e317e + рабочие изменения.</a:t>
+              <a:t>Версия: финальная поставка 22.09.2026, выпуск v1.1.0.</a:t>
             </a:r>
           </a:p>
           <a:p xmlns:a="http://schemas.openxmlformats.org/drawingml/2006/main">
@@ -1233,7 +1425,7 @@
           </a:p>
           <a:p xmlns:a="http://schemas.openxmlformats.org/drawingml/2006/main">
             <a:r>
-              <a:t>Версия: финальная поставка 22.09.2026, dev 88e317e + рабочие изменения.</a:t>
+              <a:t>Версия: финальная поставка 22.09.2026, выпуск v1.1.0.</a:t>
             </a:r>
           </a:p>
           <a:p xmlns:a="http://schemas.openxmlformats.org/drawingml/2006/main">
@@ -1328,7 +1520,7 @@
           </a:p>
           <a:p xmlns:a="http://schemas.openxmlformats.org/drawingml/2006/main">
             <a:r>
-              <a:t>Версия: финальная поставка 22.09.2026, dev 88e317e + рабочие изменения.</a:t>
+              <a:t>Версия: финальная поставка 22.09.2026, выпуск v1.1.0.</a:t>
             </a:r>
           </a:p>
           <a:p xmlns:a="http://schemas.openxmlformats.org/drawingml/2006/main">
@@ -1423,7 +1615,7 @@
           </a:p>
           <a:p xmlns:a="http://schemas.openxmlformats.org/drawingml/2006/main">
             <a:r>
-              <a:t>Версия: финальная поставка 22.09.2026, dev 88e317e + рабочие изменения.</a:t>
+              <a:t>Версия: финальная поставка 22.09.2026, выпуск v1.1.0.</a:t>
             </a:r>
           </a:p>
           <a:p xmlns:a="http://schemas.openxmlformats.org/drawingml/2006/main">
@@ -1518,7 +1710,7 @@
           </a:p>
           <a:p xmlns:a="http://schemas.openxmlformats.org/drawingml/2006/main">
             <a:r>
-              <a:t>Версия: финальная поставка 22.09.2026, dev 88e317e + рабочие изменения.</a:t>
+              <a:t>Версия: финальная поставка 22.09.2026, выпуск v1.1.0.</a:t>
             </a:r>
           </a:p>
           <a:p xmlns:a="http://schemas.openxmlformats.org/drawingml/2006/main">
@@ -1606,7 +1798,7 @@
   </p:cSld>
   <p:clrMap bg1="lt1" tx1="dk1" bg2="lt2" tx2="dk2" accent1="accent1" accent2="accent2" accent3="accent3" accent4="accent4" accent5="accent5" accent6="accent6" hlink="hlink" folHlink="folHlink"/>
   <p:sldLayoutIdLst>
-    <p:sldLayoutId xmlns:r="http://schemas.openxmlformats.org/officeDocument/2006/relationships" id="2147483649" r:id="Rf5dc73732b73458b"/>
+    <p:sldLayoutId xmlns:r="http://schemas.openxmlformats.org/officeDocument/2006/relationships" id="2147483649" r:id="Rb17edc4b213a4e2b"/>
   </p:sldLayoutIdLst>
   <p:txStyles>
     <p:titleStyle>
@@ -2161,7 +2353,7 @@
           <p:nvPr/>
         </p:nvPicPr>
         <p:blipFill>
-          <a:blip xmlns:r="http://schemas.openxmlformats.org/officeDocument/2006/relationships" xmlns:a="http://schemas.openxmlformats.org/drawingml/2006/main" r:embed="R3a425e54378e4977"/>
+          <a:blip xmlns:r="http://schemas.openxmlformats.org/officeDocument/2006/relationships" xmlns:a="http://schemas.openxmlformats.org/drawingml/2006/main" r:embed="Re38cb8f5c5eb4306"/>
           <a:srcRect xmlns:a="http://schemas.openxmlformats.org/drawingml/2006/main" l="0" t="27" r="0" b="27"/>
           <a:stretch xmlns:a="http://schemas.openxmlformats.org/drawingml/2006/main">
             <a:fillRect l="0" t="0" r="0" b="0"/>
@@ -2182,7 +2374,7 @@
           <p:cNvPr id="2" name="">
             <a:extLst xmlns:a="http://schemas.openxmlformats.org/drawingml/2006/main">
               <a:ext uri="{FF2B5EF4-FFF2-40B4-BE49-F238E27FC236}">
-                <a16:creationId xmlns:a16="http://schemas.microsoft.com/office/drawing/2014/main" id="{46905556-CE52-4A98-8663-588AAC84F1AA}"/>
+                <a16:creationId xmlns:a16="http://schemas.microsoft.com/office/drawing/2014/main" id="{A747240E-EED6-4A41-B2F0-91BE338D401B}"/>
               </a:ext>
             </a:extLst>
           </p:cNvPr>
@@ -2239,7 +2431,7 @@
           <p:cNvPr id="3" name="">
             <a:extLst xmlns:a="http://schemas.openxmlformats.org/drawingml/2006/main">
               <a:ext uri="{FF2B5EF4-FFF2-40B4-BE49-F238E27FC236}">
-                <a16:creationId xmlns:a16="http://schemas.microsoft.com/office/drawing/2014/main" id="{B6C14109-603C-4BFD-BC60-79959E3373B6}"/>
+                <a16:creationId xmlns:a16="http://schemas.microsoft.com/office/drawing/2014/main" id="{23BB1063-CAA2-43C4-AF27-53028052DE8A}"/>
               </a:ext>
             </a:extLst>
           </p:cNvPr>
@@ -2342,7 +2534,7 @@
           <p:cNvPr id="4" name="">
             <a:extLst xmlns:a="http://schemas.openxmlformats.org/drawingml/2006/main">
               <a:ext uri="{FF2B5EF4-FFF2-40B4-BE49-F238E27FC236}">
-                <a16:creationId xmlns:a16="http://schemas.microsoft.com/office/drawing/2014/main" id="{1EAD1B2A-B004-4AAD-9DCD-23DE8F232F78}"/>
+                <a16:creationId xmlns:a16="http://schemas.microsoft.com/office/drawing/2014/main" id="{CBBBD5CF-6C31-4B2A-93EA-5745DBF12AF3}"/>
               </a:ext>
             </a:extLst>
           </p:cNvPr>
@@ -2399,7 +2591,7 @@
           <p:cNvPr id="5" name="">
             <a:extLst xmlns:a="http://schemas.openxmlformats.org/drawingml/2006/main">
               <a:ext uri="{FF2B5EF4-FFF2-40B4-BE49-F238E27FC236}">
-                <a16:creationId xmlns:a16="http://schemas.microsoft.com/office/drawing/2014/main" id="{B8E4CFF9-5810-46EA-961E-DDC28C8C7E43}"/>
+                <a16:creationId xmlns:a16="http://schemas.microsoft.com/office/drawing/2014/main" id="{7A9BE7F5-EF97-4124-B891-4D8DF35BA9D1}"/>
               </a:ext>
             </a:extLst>
           </p:cNvPr>
@@ -2454,7 +2646,7 @@
     </p:spTree>
     <p:extLst>
       <p:ext uri="{BB962C8B-B14F-4D97-AF65-F5344CB8AC3E}">
-        <p14:creationId xmlns:p14="http://schemas.microsoft.com/office/powerpoint/2010/main" val="1055388455"/>
+        <p14:creationId xmlns:p14="http://schemas.microsoft.com/office/powerpoint/2010/main" val="1968834232"/>
       </p:ext>
     </p:extLst>
   </p:cSld>
@@ -2485,7 +2677,7 @@
           <p:cNvPr id="14" name="">
             <a:extLst xmlns:a="http://schemas.openxmlformats.org/drawingml/2006/main">
               <a:ext uri="{FF2B5EF4-FFF2-40B4-BE49-F238E27FC236}">
-                <a16:creationId xmlns:a16="http://schemas.microsoft.com/office/drawing/2014/main" id="{18A6F190-1195-4894-A209-E9609D41AB1D}"/>
+                <a16:creationId xmlns:a16="http://schemas.microsoft.com/office/drawing/2014/main" id="{656F186D-8E6F-4D3A-94F8-6B13DA7770DF}"/>
               </a:ext>
             </a:extLst>
           </p:cNvPr>
@@ -2542,7 +2734,7 @@
           <p:cNvPr id="2" name="">
             <a:extLst xmlns:a="http://schemas.openxmlformats.org/drawingml/2006/main">
               <a:ext uri="{FF2B5EF4-FFF2-40B4-BE49-F238E27FC236}">
-                <a16:creationId xmlns:a16="http://schemas.microsoft.com/office/drawing/2014/main" id="{C3E18C7A-9FA7-49DA-AC55-973DE08F5E09}"/>
+                <a16:creationId xmlns:a16="http://schemas.microsoft.com/office/drawing/2014/main" id="{6B58D290-5350-4C63-B455-209408FA0CD6}"/>
               </a:ext>
             </a:extLst>
           </p:cNvPr>
@@ -2599,7 +2791,7 @@
           <p:cNvPr id="3" name="">
             <a:extLst xmlns:a="http://schemas.openxmlformats.org/drawingml/2006/main">
               <a:ext uri="{FF2B5EF4-FFF2-40B4-BE49-F238E27FC236}">
-                <a16:creationId xmlns:a16="http://schemas.microsoft.com/office/drawing/2014/main" id="{D247A7F1-0551-4373-B964-101EF412D311}"/>
+                <a16:creationId xmlns:a16="http://schemas.microsoft.com/office/drawing/2014/main" id="{D70D1F7F-8703-4E32-A2F3-B4811D00D193}"/>
               </a:ext>
             </a:extLst>
           </p:cNvPr>
@@ -2656,7 +2848,7 @@
           <p:cNvPr id="4" name="">
             <a:extLst xmlns:a="http://schemas.openxmlformats.org/drawingml/2006/main">
               <a:ext uri="{FF2B5EF4-FFF2-40B4-BE49-F238E27FC236}">
-                <a16:creationId xmlns:a16="http://schemas.microsoft.com/office/drawing/2014/main" id="{26979164-9DA5-49D5-AEA9-17173F896D1D}"/>
+                <a16:creationId xmlns:a16="http://schemas.microsoft.com/office/drawing/2014/main" id="{6060D954-2DD1-4230-83F0-CCB2A663A6C6}"/>
               </a:ext>
             </a:extLst>
           </p:cNvPr>
@@ -2713,7 +2905,7 @@
           <p:cNvPr id="5" name="">
             <a:extLst xmlns:a="http://schemas.openxmlformats.org/drawingml/2006/main">
               <a:ext uri="{FF2B5EF4-FFF2-40B4-BE49-F238E27FC236}">
-                <a16:creationId xmlns:a16="http://schemas.microsoft.com/office/drawing/2014/main" id="{4FB124C4-D93C-4A52-8F10-37AF910232D3}"/>
+                <a16:creationId xmlns:a16="http://schemas.microsoft.com/office/drawing/2014/main" id="{EFBE2D33-CC82-4B09-A515-55442026EB22}"/>
               </a:ext>
             </a:extLst>
           </p:cNvPr>
@@ -2770,7 +2962,7 @@
           <p:cNvPr id="6" name="">
             <a:extLst xmlns:a="http://schemas.openxmlformats.org/drawingml/2006/main">
               <a:ext uri="{FF2B5EF4-FFF2-40B4-BE49-F238E27FC236}">
-                <a16:creationId xmlns:a16="http://schemas.microsoft.com/office/drawing/2014/main" id="{FE0A0BC3-DF63-4F3C-8FD8-1AF6C416015F}"/>
+                <a16:creationId xmlns:a16="http://schemas.microsoft.com/office/drawing/2014/main" id="{85CC40C7-FD52-46A0-8072-720A69B24A9B}"/>
               </a:ext>
             </a:extLst>
           </p:cNvPr>
@@ -2827,7 +3019,7 @@
           <p:cNvPr id="7" name="">
             <a:extLst xmlns:a="http://schemas.openxmlformats.org/drawingml/2006/main">
               <a:ext uri="{FF2B5EF4-FFF2-40B4-BE49-F238E27FC236}">
-                <a16:creationId xmlns:a16="http://schemas.microsoft.com/office/drawing/2014/main" id="{0175597E-5EF6-4207-9841-9AF4320C682E}"/>
+                <a16:creationId xmlns:a16="http://schemas.microsoft.com/office/drawing/2014/main" id="{9E4697DB-CBF4-46D5-B61D-F213DA6A869A}"/>
               </a:ext>
             </a:extLst>
           </p:cNvPr>
@@ -2884,7 +3076,7 @@
           <p:cNvPr id="8" name="">
             <a:extLst xmlns:a="http://schemas.openxmlformats.org/drawingml/2006/main">
               <a:ext uri="{FF2B5EF4-FFF2-40B4-BE49-F238E27FC236}">
-                <a16:creationId xmlns:a16="http://schemas.microsoft.com/office/drawing/2014/main" id="{78F33B4F-DED6-482F-95C0-0D937F89D1C0}"/>
+                <a16:creationId xmlns:a16="http://schemas.microsoft.com/office/drawing/2014/main" id="{D1634194-ED1B-4FD4-9D36-D947B87F7C79}"/>
               </a:ext>
             </a:extLst>
           </p:cNvPr>
@@ -2941,7 +3133,7 @@
           <p:cNvPr id="9" name="">
             <a:extLst xmlns:a="http://schemas.openxmlformats.org/drawingml/2006/main">
               <a:ext uri="{FF2B5EF4-FFF2-40B4-BE49-F238E27FC236}">
-                <a16:creationId xmlns:a16="http://schemas.microsoft.com/office/drawing/2014/main" id="{46D6AA54-CA51-4030-A40C-C3E1EA19BD05}"/>
+                <a16:creationId xmlns:a16="http://schemas.microsoft.com/office/drawing/2014/main" id="{90466676-7D8F-4186-9152-1B381CDA4BFE}"/>
               </a:ext>
             </a:extLst>
           </p:cNvPr>
@@ -2998,7 +3190,7 @@
           <p:cNvPr id="10" name="">
             <a:extLst xmlns:a="http://schemas.openxmlformats.org/drawingml/2006/main">
               <a:ext uri="{FF2B5EF4-FFF2-40B4-BE49-F238E27FC236}">
-                <a16:creationId xmlns:a16="http://schemas.microsoft.com/office/drawing/2014/main" id="{07855D18-85E6-4029-8496-CBFD47930D8E}"/>
+                <a16:creationId xmlns:a16="http://schemas.microsoft.com/office/drawing/2014/main" id="{A9D941B0-D40F-41CC-A58C-E11DD6A25B46}"/>
               </a:ext>
             </a:extLst>
           </p:cNvPr>
@@ -3055,7 +3247,7 @@
           <p:cNvPr id="11" name="">
             <a:extLst xmlns:a="http://schemas.openxmlformats.org/drawingml/2006/main">
               <a:ext uri="{FF2B5EF4-FFF2-40B4-BE49-F238E27FC236}">
-                <a16:creationId xmlns:a16="http://schemas.microsoft.com/office/drawing/2014/main" id="{83A9D395-C642-4060-A325-67625D01BB6A}"/>
+                <a16:creationId xmlns:a16="http://schemas.microsoft.com/office/drawing/2014/main" id="{32FFDDD9-EB94-4B25-832E-7633ECD3BF13}"/>
               </a:ext>
             </a:extLst>
           </p:cNvPr>
@@ -3112,7 +3304,7 @@
           <p:cNvPr id="12" name="">
             <a:extLst xmlns:a="http://schemas.openxmlformats.org/drawingml/2006/main">
               <a:ext uri="{FF2B5EF4-FFF2-40B4-BE49-F238E27FC236}">
-                <a16:creationId xmlns:a16="http://schemas.microsoft.com/office/drawing/2014/main" id="{388C2FFF-B39D-45A8-B733-39F9252D9A0B}"/>
+                <a16:creationId xmlns:a16="http://schemas.microsoft.com/office/drawing/2014/main" id="{9C3539C7-B98D-4747-A6C0-6A1BBBBFFEC6}"/>
               </a:ext>
             </a:extLst>
           </p:cNvPr>
@@ -3169,7 +3361,7 @@
           <p:cNvPr id="13" name="">
             <a:extLst xmlns:a="http://schemas.openxmlformats.org/drawingml/2006/main">
               <a:ext uri="{FF2B5EF4-FFF2-40B4-BE49-F238E27FC236}">
-                <a16:creationId xmlns:a16="http://schemas.microsoft.com/office/drawing/2014/main" id="{DF5A58C7-CAFB-4AEF-869A-4F5B459568D6}"/>
+                <a16:creationId xmlns:a16="http://schemas.microsoft.com/office/drawing/2014/main" id="{8B9A2F71-87C5-451A-8F75-4B530A5DDCB1}"/>
               </a:ext>
             </a:extLst>
           </p:cNvPr>
@@ -3224,7 +3416,7 @@
     </p:spTree>
     <p:extLst>
       <p:ext uri="{BB962C8B-B14F-4D97-AF65-F5344CB8AC3E}">
-        <p14:creationId xmlns:p14="http://schemas.microsoft.com/office/powerpoint/2010/main" val="206250351"/>
+        <p14:creationId xmlns:p14="http://schemas.microsoft.com/office/powerpoint/2010/main" val="396024516"/>
       </p:ext>
     </p:extLst>
   </p:cSld>
@@ -3255,7 +3447,7 @@
           <p:cNvPr id="14" name="">
             <a:extLst xmlns:a="http://schemas.openxmlformats.org/drawingml/2006/main">
               <a:ext uri="{FF2B5EF4-FFF2-40B4-BE49-F238E27FC236}">
-                <a16:creationId xmlns:a16="http://schemas.microsoft.com/office/drawing/2014/main" id="{30F7650E-919A-449F-88CA-AE3027D643ED}"/>
+                <a16:creationId xmlns:a16="http://schemas.microsoft.com/office/drawing/2014/main" id="{308E7F27-D68D-4D7C-80FF-88C083A56B86}"/>
               </a:ext>
             </a:extLst>
           </p:cNvPr>
@@ -3312,7 +3504,7 @@
           <p:cNvPr id="2" name="">
             <a:extLst xmlns:a="http://schemas.openxmlformats.org/drawingml/2006/main">
               <a:ext uri="{FF2B5EF4-FFF2-40B4-BE49-F238E27FC236}">
-                <a16:creationId xmlns:a16="http://schemas.microsoft.com/office/drawing/2014/main" id="{FB2BFFF6-7C1C-46C1-82DB-6F0C12E7608D}"/>
+                <a16:creationId xmlns:a16="http://schemas.microsoft.com/office/drawing/2014/main" id="{522E1CA1-FD1C-4AA6-A0BC-183E6487AD65}"/>
               </a:ext>
             </a:extLst>
           </p:cNvPr>
@@ -3369,7 +3561,7 @@
           <p:cNvPr id="3" name="">
             <a:extLst xmlns:a="http://schemas.openxmlformats.org/drawingml/2006/main">
               <a:ext uri="{FF2B5EF4-FFF2-40B4-BE49-F238E27FC236}">
-                <a16:creationId xmlns:a16="http://schemas.microsoft.com/office/drawing/2014/main" id="{378A8046-C183-4F5D-BFF0-7F8643870CD8}"/>
+                <a16:creationId xmlns:a16="http://schemas.microsoft.com/office/drawing/2014/main" id="{04AECA95-7A1D-497A-9308-D0EA52961313}"/>
               </a:ext>
             </a:extLst>
           </p:cNvPr>
@@ -3426,7 +3618,7 @@
           <p:cNvPr id="4" name="">
             <a:extLst xmlns:a="http://schemas.openxmlformats.org/drawingml/2006/main">
               <a:ext uri="{FF2B5EF4-FFF2-40B4-BE49-F238E27FC236}">
-                <a16:creationId xmlns:a16="http://schemas.microsoft.com/office/drawing/2014/main" id="{734BE39C-D816-4533-9DC9-B250DAD3EDC9}"/>
+                <a16:creationId xmlns:a16="http://schemas.microsoft.com/office/drawing/2014/main" id="{CD2B2741-2D8C-4CDB-B601-6FB369BE816E}"/>
               </a:ext>
             </a:extLst>
           </p:cNvPr>
@@ -3483,7 +3675,7 @@
           <p:cNvPr id="5" name="">
             <a:extLst xmlns:a="http://schemas.openxmlformats.org/drawingml/2006/main">
               <a:ext uri="{FF2B5EF4-FFF2-40B4-BE49-F238E27FC236}">
-                <a16:creationId xmlns:a16="http://schemas.microsoft.com/office/drawing/2014/main" id="{78B1D1F0-0A62-45BF-920A-84A760C219C2}"/>
+                <a16:creationId xmlns:a16="http://schemas.microsoft.com/office/drawing/2014/main" id="{E9F70722-AF3C-4CDE-A426-DF764F1790A1}"/>
               </a:ext>
             </a:extLst>
           </p:cNvPr>
@@ -3540,7 +3732,7 @@
           <p:cNvPr id="6" name="">
             <a:extLst xmlns:a="http://schemas.openxmlformats.org/drawingml/2006/main">
               <a:ext uri="{FF2B5EF4-FFF2-40B4-BE49-F238E27FC236}">
-                <a16:creationId xmlns:a16="http://schemas.microsoft.com/office/drawing/2014/main" id="{111C781F-0710-450D-B73E-50F1D8533326}"/>
+                <a16:creationId xmlns:a16="http://schemas.microsoft.com/office/drawing/2014/main" id="{AE114B3E-D381-4AFD-AB53-4E5C40C22E9B}"/>
               </a:ext>
             </a:extLst>
           </p:cNvPr>
@@ -3597,7 +3789,7 @@
           <p:cNvPr id="7" name="">
             <a:extLst xmlns:a="http://schemas.openxmlformats.org/drawingml/2006/main">
               <a:ext uri="{FF2B5EF4-FFF2-40B4-BE49-F238E27FC236}">
-                <a16:creationId xmlns:a16="http://schemas.microsoft.com/office/drawing/2014/main" id="{2F245268-4B3B-41AC-8B8F-7B2DFCB8CCF4}"/>
+                <a16:creationId xmlns:a16="http://schemas.microsoft.com/office/drawing/2014/main" id="{13CD1BEA-A5F5-44AD-BB0D-3AC8C3EA12CB}"/>
               </a:ext>
             </a:extLst>
           </p:cNvPr>
@@ -3654,7 +3846,7 @@
           <p:cNvPr id="8" name="">
             <a:extLst xmlns:a="http://schemas.openxmlformats.org/drawingml/2006/main">
               <a:ext uri="{FF2B5EF4-FFF2-40B4-BE49-F238E27FC236}">
-                <a16:creationId xmlns:a16="http://schemas.microsoft.com/office/drawing/2014/main" id="{E9211757-5A1D-42B1-9432-67AE2A487C90}"/>
+                <a16:creationId xmlns:a16="http://schemas.microsoft.com/office/drawing/2014/main" id="{D025EE9C-6B31-4958-B59F-85F38F13D981}"/>
               </a:ext>
             </a:extLst>
           </p:cNvPr>
@@ -3711,7 +3903,7 @@
           <p:cNvPr id="9" name="">
             <a:extLst xmlns:a="http://schemas.openxmlformats.org/drawingml/2006/main">
               <a:ext uri="{FF2B5EF4-FFF2-40B4-BE49-F238E27FC236}">
-                <a16:creationId xmlns:a16="http://schemas.microsoft.com/office/drawing/2014/main" id="{45716187-0A11-4BA8-939A-DC7ED8971182}"/>
+                <a16:creationId xmlns:a16="http://schemas.microsoft.com/office/drawing/2014/main" id="{BD58D852-9A2B-4A54-ADA3-C7F1C0DD38CB}"/>
               </a:ext>
             </a:extLst>
           </p:cNvPr>
@@ -3768,7 +3960,7 @@
           <p:cNvPr id="10" name="">
             <a:extLst xmlns:a="http://schemas.openxmlformats.org/drawingml/2006/main">
               <a:ext uri="{FF2B5EF4-FFF2-40B4-BE49-F238E27FC236}">
-                <a16:creationId xmlns:a16="http://schemas.microsoft.com/office/drawing/2014/main" id="{81CAEBBE-D878-49E1-AEBA-47F14133C06C}"/>
+                <a16:creationId xmlns:a16="http://schemas.microsoft.com/office/drawing/2014/main" id="{16FD0296-A53F-41F4-81FD-6E18392FD9BB}"/>
               </a:ext>
             </a:extLst>
           </p:cNvPr>
@@ -3825,7 +4017,7 @@
           <p:cNvPr id="11" name="">
             <a:extLst xmlns:a="http://schemas.openxmlformats.org/drawingml/2006/main">
               <a:ext uri="{FF2B5EF4-FFF2-40B4-BE49-F238E27FC236}">
-                <a16:creationId xmlns:a16="http://schemas.microsoft.com/office/drawing/2014/main" id="{59583A68-2DFC-41E2-A958-3EDC8363D7E0}"/>
+                <a16:creationId xmlns:a16="http://schemas.microsoft.com/office/drawing/2014/main" id="{2F46AA9D-657C-4881-9E02-BF5EA22DFCA6}"/>
               </a:ext>
             </a:extLst>
           </p:cNvPr>
@@ -3882,7 +4074,7 @@
           <p:cNvPr id="12" name="">
             <a:extLst xmlns:a="http://schemas.openxmlformats.org/drawingml/2006/main">
               <a:ext uri="{FF2B5EF4-FFF2-40B4-BE49-F238E27FC236}">
-                <a16:creationId xmlns:a16="http://schemas.microsoft.com/office/drawing/2014/main" id="{C603659E-55E6-474A-8F47-28492C567983}"/>
+                <a16:creationId xmlns:a16="http://schemas.microsoft.com/office/drawing/2014/main" id="{C7C6F5AF-FA48-4216-B0C2-86118631A3C8}"/>
               </a:ext>
             </a:extLst>
           </p:cNvPr>
@@ -3939,7 +4131,7 @@
           <p:cNvPr id="13" name="">
             <a:extLst xmlns:a="http://schemas.openxmlformats.org/drawingml/2006/main">
               <a:ext uri="{FF2B5EF4-FFF2-40B4-BE49-F238E27FC236}">
-                <a16:creationId xmlns:a16="http://schemas.microsoft.com/office/drawing/2014/main" id="{A51DDC65-72D6-45E4-80E4-CED543180145}"/>
+                <a16:creationId xmlns:a16="http://schemas.microsoft.com/office/drawing/2014/main" id="{72263E8B-9C94-41BE-8021-A3F553B64F50}"/>
               </a:ext>
             </a:extLst>
           </p:cNvPr>
@@ -3994,7 +4186,7 @@
     </p:spTree>
     <p:extLst>
       <p:ext uri="{BB962C8B-B14F-4D97-AF65-F5344CB8AC3E}">
-        <p14:creationId xmlns:p14="http://schemas.microsoft.com/office/powerpoint/2010/main" val="1378380764"/>
+        <p14:creationId xmlns:p14="http://schemas.microsoft.com/office/powerpoint/2010/main" val="1513784716"/>
       </p:ext>
     </p:extLst>
   </p:cSld>
@@ -4002,6 +4194,1272 @@
 </file>
 
 <file path=ppt/slides/slide12.xml><?xml version="1.0" encoding="utf-8"?>
+<p:sld xmlns:p="http://schemas.openxmlformats.org/presentationml/2006/main">
+  <p:cSld>
+    <p:bg>
+      <p:bgPr>
+        <a:solidFill xmlns:a="http://schemas.openxmlformats.org/drawingml/2006/main">
+          <a:srgbClr val="F2F3EF"/>
+        </a:solidFill>
+      </p:bgPr>
+    </p:bg>
+    <p:spTree>
+      <p:nvGrpSpPr>
+        <p:cNvPr id="1" name=""/>
+        <p:cNvGrpSpPr/>
+        <p:nvPr/>
+      </p:nvGrpSpPr>
+      <p:grpSpPr>
+        <a:xfrm xmlns:a="http://schemas.openxmlformats.org/drawingml/2006/main"/>
+      </p:grpSpPr>
+      <p:sp>
+        <p:nvSpPr>
+          <p:cNvPr id="12" name="">
+            <a:extLst xmlns:a="http://schemas.openxmlformats.org/drawingml/2006/main">
+              <a:ext uri="{FF2B5EF4-FFF2-40B4-BE49-F238E27FC236}">
+                <a16:creationId xmlns:a16="http://schemas.microsoft.com/office/drawing/2014/main" id="{52C1512A-CB9E-48CA-A8F0-4E03EEAE49AB}"/>
+              </a:ext>
+            </a:extLst>
+          </p:cNvPr>
+          <p:cNvSpPr>
+            <a:spLocks xmlns:a="http://schemas.openxmlformats.org/drawingml/2006/main" noGrp="1"/>
+          </p:cNvSpPr>
+          <p:nvPr/>
+        </p:nvSpPr>
+        <p:spPr>
+          <a:xfrm xmlns:a="http://schemas.openxmlformats.org/drawingml/2006/main">
+            <a:off x="609600" y="304800"/>
+            <a:ext cx="9525000" cy="266700"/>
+          </a:xfrm>
+          <a:prstGeom xmlns:a="http://schemas.openxmlformats.org/drawingml/2006/main" prst="rect">
+            <a:avLst/>
+          </a:prstGeom>
+          <a:noFill xmlns:a="http://schemas.openxmlformats.org/drawingml/2006/main"/>
+          <a:ln xmlns:a="http://schemas.openxmlformats.org/drawingml/2006/main" w="0">
+            <a:noFill/>
+          </a:ln>
+        </p:spPr>
+        <p:txBody>
+          <a:bodyPr xmlns:a="http://schemas.openxmlformats.org/drawingml/2006/main" anchor="t">
+            <a:noAutofit/>
+          </a:bodyPr>
+          <a:lstStyle xmlns:a="http://schemas.openxmlformats.org/drawingml/2006/main"/>
+          <a:p xmlns:a="http://schemas.openxmlformats.org/drawingml/2006/main">
+            <a:pPr>
+              <a:defRPr sz="1200" b="1">
+                <a:solidFill>
+                  <a:srgbClr val="007F7B"/>
+                </a:solidFill>
+                <a:latin typeface="Arial"/>
+                <a:ea typeface="Arial"/>
+                <a:cs typeface="Arial"/>
+              </a:defRPr>
+            </a:pPr>
+            <a:r>
+              <a:rPr sz="1200" b="1">
+                <a:solidFill>
+                  <a:srgbClr val="007F7B"/>
+                </a:solidFill>
+                <a:latin typeface="Arial"/>
+                <a:ea typeface="Arial"/>
+                <a:cs typeface="Arial"/>
+              </a:rPr>
+              <a:t>НОВОЕ В v1.1.0</a:t>
+            </a:r>
+          </a:p>
+        </p:txBody>
+      </p:sp>
+      <p:sp>
+        <p:nvSpPr>
+          <p:cNvPr id="2" name="">
+            <a:extLst xmlns:a="http://schemas.openxmlformats.org/drawingml/2006/main">
+              <a:ext uri="{FF2B5EF4-FFF2-40B4-BE49-F238E27FC236}">
+                <a16:creationId xmlns:a16="http://schemas.microsoft.com/office/drawing/2014/main" id="{2F7AA190-08CD-4CB4-B8BD-4B44D1EB3C88}"/>
+              </a:ext>
+            </a:extLst>
+          </p:cNvPr>
+          <p:cNvSpPr>
+            <a:spLocks xmlns:a="http://schemas.openxmlformats.org/drawingml/2006/main" noGrp="1"/>
+          </p:cNvSpPr>
+          <p:nvPr/>
+        </p:nvSpPr>
+        <p:spPr>
+          <a:xfrm xmlns:a="http://schemas.openxmlformats.org/drawingml/2006/main">
+            <a:off x="609600" y="790575"/>
+            <a:ext cx="10972800" cy="1066800"/>
+          </a:xfrm>
+          <a:prstGeom xmlns:a="http://schemas.openxmlformats.org/drawingml/2006/main" prst="rect">
+            <a:avLst/>
+          </a:prstGeom>
+          <a:noFill xmlns:a="http://schemas.openxmlformats.org/drawingml/2006/main"/>
+          <a:ln xmlns:a="http://schemas.openxmlformats.org/drawingml/2006/main" w="0">
+            <a:noFill/>
+          </a:ln>
+        </p:spPr>
+        <p:txBody>
+          <a:bodyPr xmlns:a="http://schemas.openxmlformats.org/drawingml/2006/main" anchor="t">
+            <a:noAutofit/>
+          </a:bodyPr>
+          <a:lstStyle xmlns:a="http://schemas.openxmlformats.org/drawingml/2006/main"/>
+          <a:p xmlns:a="http://schemas.openxmlformats.org/drawingml/2006/main">
+            <a:pPr>
+              <a:defRPr sz="3450" b="1">
+                <a:solidFill>
+                  <a:srgbClr val="14252C"/>
+                </a:solidFill>
+                <a:latin typeface="Arial"/>
+                <a:ea typeface="Arial"/>
+                <a:cs typeface="Arial"/>
+              </a:defRPr>
+            </a:pPr>
+            <a:r>
+              <a:rPr sz="3450" b="1">
+                <a:solidFill>
+                  <a:srgbClr val="14252C"/>
+                </a:solidFill>
+                <a:latin typeface="Arial"/>
+                <a:ea typeface="Arial"/>
+                <a:cs typeface="Arial"/>
+              </a:rPr>
+              <a:t>Синтетический what-if для живого показа</a:t>
+            </a:r>
+          </a:p>
+        </p:txBody>
+      </p:sp>
+      <p:sp>
+        <p:nvSpPr>
+          <p:cNvPr id="3" name="">
+            <a:extLst xmlns:a="http://schemas.openxmlformats.org/drawingml/2006/main">
+              <a:ext uri="{FF2B5EF4-FFF2-40B4-BE49-F238E27FC236}">
+                <a16:creationId xmlns:a16="http://schemas.microsoft.com/office/drawing/2014/main" id="{85A75C66-F24C-4FDA-8307-21427D77CADE}"/>
+              </a:ext>
+            </a:extLst>
+          </p:cNvPr>
+          <p:cNvSpPr>
+            <a:spLocks xmlns:a="http://schemas.openxmlformats.org/drawingml/2006/main" noGrp="1"/>
+          </p:cNvSpPr>
+          <p:nvPr/>
+        </p:nvSpPr>
+        <p:spPr>
+          <a:xfrm xmlns:a="http://schemas.openxmlformats.org/drawingml/2006/main">
+            <a:off x="609600" y="6438900"/>
+            <a:ext cx="9906000" cy="209550"/>
+          </a:xfrm>
+          <a:prstGeom xmlns:a="http://schemas.openxmlformats.org/drawingml/2006/main" prst="rect">
+            <a:avLst/>
+          </a:prstGeom>
+          <a:noFill xmlns:a="http://schemas.openxmlformats.org/drawingml/2006/main"/>
+          <a:ln xmlns:a="http://schemas.openxmlformats.org/drawingml/2006/main" w="0">
+            <a:noFill/>
+          </a:ln>
+        </p:spPr>
+        <p:txBody>
+          <a:bodyPr xmlns:a="http://schemas.openxmlformats.org/drawingml/2006/main" anchor="t">
+            <a:noAutofit/>
+          </a:bodyPr>
+          <a:lstStyle xmlns:a="http://schemas.openxmlformats.org/drawingml/2006/main"/>
+          <a:p xmlns:a="http://schemas.openxmlformats.org/drawingml/2006/main">
+            <a:pPr>
+              <a:defRPr sz="975" b="0">
+                <a:solidFill>
+                  <a:srgbClr val="586C73"/>
+                </a:solidFill>
+                <a:latin typeface="Arial"/>
+                <a:ea typeface="Arial"/>
+                <a:cs typeface="Arial"/>
+              </a:defRPr>
+            </a:pPr>
+            <a:r>
+              <a:rPr sz="975" b="0">
+                <a:solidFill>
+                  <a:srgbClr val="586C73"/>
+                </a:solidFill>
+                <a:latin typeface="Arial"/>
+                <a:ea typeface="Arial"/>
+                <a:cs typeface="Arial"/>
+              </a:rPr>
+              <a:t>НЕФТЕКОД 2.0  /  СИСТЕМА ПОДДЕРЖКИ РЕШЕНИЙ</a:t>
+            </a:r>
+          </a:p>
+        </p:txBody>
+      </p:sp>
+      <p:sp>
+        <p:nvSpPr>
+          <p:cNvPr id="4" name="">
+            <a:extLst xmlns:a="http://schemas.openxmlformats.org/drawingml/2006/main">
+              <a:ext uri="{FF2B5EF4-FFF2-40B4-BE49-F238E27FC236}">
+                <a16:creationId xmlns:a16="http://schemas.microsoft.com/office/drawing/2014/main" id="{25920AA3-58A5-4FBB-87DC-D4ED6BDF9A40}"/>
+              </a:ext>
+            </a:extLst>
+          </p:cNvPr>
+          <p:cNvSpPr>
+            <a:spLocks xmlns:a="http://schemas.openxmlformats.org/drawingml/2006/main" noGrp="1"/>
+          </p:cNvSpPr>
+          <p:nvPr/>
+        </p:nvSpPr>
+        <p:spPr>
+          <a:xfrm xmlns:a="http://schemas.openxmlformats.org/drawingml/2006/main">
+            <a:off x="11153775" y="6410325"/>
+            <a:ext cx="523875" cy="257175"/>
+          </a:xfrm>
+          <a:prstGeom xmlns:a="http://schemas.openxmlformats.org/drawingml/2006/main" prst="rect">
+            <a:avLst/>
+          </a:prstGeom>
+          <a:noFill xmlns:a="http://schemas.openxmlformats.org/drawingml/2006/main"/>
+          <a:ln xmlns:a="http://schemas.openxmlformats.org/drawingml/2006/main" w="0">
+            <a:noFill/>
+          </a:ln>
+        </p:spPr>
+        <p:txBody>
+          <a:bodyPr xmlns:a="http://schemas.openxmlformats.org/drawingml/2006/main" anchor="t">
+            <a:noAutofit/>
+          </a:bodyPr>
+          <a:lstStyle xmlns:a="http://schemas.openxmlformats.org/drawingml/2006/main"/>
+          <a:p xmlns:a="http://schemas.openxmlformats.org/drawingml/2006/main">
+            <a:pPr>
+              <a:defRPr sz="1350" b="1">
+                <a:solidFill>
+                  <a:srgbClr val="007F7B"/>
+                </a:solidFill>
+                <a:latin typeface="Arial"/>
+                <a:ea typeface="Arial"/>
+                <a:cs typeface="Arial"/>
+              </a:defRPr>
+            </a:pPr>
+            <a:r>
+              <a:rPr sz="1350" b="1">
+                <a:solidFill>
+                  <a:srgbClr val="007F7B"/>
+                </a:solidFill>
+                <a:latin typeface="Arial"/>
+                <a:ea typeface="Arial"/>
+                <a:cs typeface="Arial"/>
+              </a:rPr>
+              <a:t>12</a:t>
+            </a:r>
+          </a:p>
+        </p:txBody>
+      </p:sp>
+      <p:pic>
+        <p:nvPicPr>
+          <p:cNvPr id="16" name=""/>
+          <p:cNvPicPr>
+            <a:picLocks xmlns:a="http://schemas.openxmlformats.org/drawingml/2006/main" noChangeAspect="1"/>
+          </p:cNvPicPr>
+          <p:nvPr/>
+        </p:nvPicPr>
+        <p:blipFill>
+          <a:blip xmlns:r="http://schemas.openxmlformats.org/officeDocument/2006/relationships" xmlns:a="http://schemas.openxmlformats.org/drawingml/2006/main" r:embed="R1c4efcdb083f4924"/>
+          <a:stretch xmlns:a="http://schemas.openxmlformats.org/drawingml/2006/main"/>
+        </p:blipFill>
+        <p:spPr>
+          <a:xfrm xmlns:a="http://schemas.openxmlformats.org/drawingml/2006/main">
+            <a:off x="1833332" y="1809750"/>
+            <a:ext cx="3219910" cy="4495800"/>
+          </a:xfrm>
+          <a:prstGeom xmlns:a="http://schemas.openxmlformats.org/drawingml/2006/main" prst="rect">
+            <a:avLst/>
+          </a:prstGeom>
+        </p:spPr>
+      </p:pic>
+      <p:sp>
+        <p:nvSpPr>
+          <p:cNvPr id="6" name="">
+            <a:extLst xmlns:a="http://schemas.openxmlformats.org/drawingml/2006/main">
+              <a:ext uri="{FF2B5EF4-FFF2-40B4-BE49-F238E27FC236}">
+                <a16:creationId xmlns:a16="http://schemas.microsoft.com/office/drawing/2014/main" id="{5ED28E48-488F-4ED1-B9ED-7F08E9CBC2E0}"/>
+              </a:ext>
+            </a:extLst>
+          </p:cNvPr>
+          <p:cNvSpPr>
+            <a:spLocks xmlns:a="http://schemas.openxmlformats.org/drawingml/2006/main" noGrp="1"/>
+          </p:cNvSpPr>
+          <p:nvPr/>
+        </p:nvSpPr>
+        <p:spPr>
+          <a:xfrm xmlns:a="http://schemas.openxmlformats.org/drawingml/2006/main">
+            <a:off x="6858000" y="2152650"/>
+            <a:ext cx="4714875" cy="457200"/>
+          </a:xfrm>
+          <a:prstGeom xmlns:a="http://schemas.openxmlformats.org/drawingml/2006/main" prst="rect">
+            <a:avLst/>
+          </a:prstGeom>
+          <a:noFill xmlns:a="http://schemas.openxmlformats.org/drawingml/2006/main"/>
+          <a:ln xmlns:a="http://schemas.openxmlformats.org/drawingml/2006/main" w="0">
+            <a:noFill/>
+          </a:ln>
+        </p:spPr>
+        <p:txBody>
+          <a:bodyPr xmlns:a="http://schemas.openxmlformats.org/drawingml/2006/main" anchor="t">
+            <a:noAutofit/>
+          </a:bodyPr>
+          <a:lstStyle xmlns:a="http://schemas.openxmlformats.org/drawingml/2006/main"/>
+          <a:p xmlns:a="http://schemas.openxmlformats.org/drawingml/2006/main">
+            <a:pPr>
+              <a:defRPr sz="2250" b="1">
+                <a:solidFill>
+                  <a:srgbClr val="007F7B"/>
+                </a:solidFill>
+                <a:latin typeface="Arial"/>
+                <a:ea typeface="Arial"/>
+                <a:cs typeface="Arial"/>
+              </a:defRPr>
+            </a:pPr>
+            <a:r>
+              <a:rPr sz="2250" b="1">
+                <a:solidFill>
+                  <a:srgbClr val="007F7B"/>
+                </a:solidFill>
+                <a:latin typeface="Arial"/>
+                <a:ea typeface="Arial"/>
+                <a:cs typeface="Arial"/>
+              </a:rPr>
+              <a:t>1. Открыть редактор</a:t>
+            </a:r>
+          </a:p>
+        </p:txBody>
+      </p:sp>
+      <p:sp>
+        <p:nvSpPr>
+          <p:cNvPr id="7" name="">
+            <a:extLst xmlns:a="http://schemas.openxmlformats.org/drawingml/2006/main">
+              <a:ext uri="{FF2B5EF4-FFF2-40B4-BE49-F238E27FC236}">
+                <a16:creationId xmlns:a16="http://schemas.microsoft.com/office/drawing/2014/main" id="{1E6D2109-29B0-4619-A057-5C2C0678631B}"/>
+              </a:ext>
+            </a:extLst>
+          </p:cNvPr>
+          <p:cNvSpPr>
+            <a:spLocks xmlns:a="http://schemas.openxmlformats.org/drawingml/2006/main" noGrp="1"/>
+          </p:cNvSpPr>
+          <p:nvPr/>
+        </p:nvSpPr>
+        <p:spPr>
+          <a:xfrm xmlns:a="http://schemas.openxmlformats.org/drawingml/2006/main">
+            <a:off x="6858000" y="2695575"/>
+            <a:ext cx="4667250" cy="847725"/>
+          </a:xfrm>
+          <a:prstGeom xmlns:a="http://schemas.openxmlformats.org/drawingml/2006/main" prst="rect">
+            <a:avLst/>
+          </a:prstGeom>
+          <a:noFill xmlns:a="http://schemas.openxmlformats.org/drawingml/2006/main"/>
+          <a:ln xmlns:a="http://schemas.openxmlformats.org/drawingml/2006/main" w="0">
+            <a:noFill/>
+          </a:ln>
+        </p:spPr>
+        <p:txBody>
+          <a:bodyPr xmlns:a="http://schemas.openxmlformats.org/drawingml/2006/main" anchor="t">
+            <a:noAutofit/>
+          </a:bodyPr>
+          <a:lstStyle xmlns:a="http://schemas.openxmlformats.org/drawingml/2006/main"/>
+          <a:p xmlns:a="http://schemas.openxmlformats.org/drawingml/2006/main">
+            <a:pPr>
+              <a:defRPr sz="2025" b="0">
+                <a:solidFill>
+                  <a:srgbClr val="14252C"/>
+                </a:solidFill>
+                <a:latin typeface="Arial"/>
+                <a:ea typeface="Arial"/>
+                <a:cs typeface="Arial"/>
+              </a:defRPr>
+            </a:pPr>
+            <a:r>
+              <a:rPr sz="2025" b="0">
+                <a:solidFill>
+                  <a:srgbClr val="14252C"/>
+                </a:solidFill>
+                <a:latin typeface="Arial"/>
+                <a:ea typeface="Arial"/>
+                <a:cs typeface="Arial"/>
+              </a:rPr>
+              <a:t>«Обзор» или «Смесь» →</a:t>
+            </a:r>
+          </a:p>
+          <a:p xmlns:a="http://schemas.openxmlformats.org/drawingml/2006/main">
+            <a:pPr>
+              <a:defRPr sz="2025" b="0">
+                <a:solidFill>
+                  <a:srgbClr val="14252C"/>
+                </a:solidFill>
+                <a:latin typeface="Arial"/>
+                <a:ea typeface="Arial"/>
+                <a:cs typeface="Arial"/>
+              </a:defRPr>
+            </a:pPr>
+            <a:r>
+              <a:rPr sz="2025" b="0">
+                <a:solidFill>
+                  <a:srgbClr val="14252C"/>
+                </a:solidFill>
+                <a:latin typeface="Arial"/>
+                <a:ea typeface="Arial"/>
+                <a:cs typeface="Arial"/>
+              </a:rPr>
+              <a:t>«Синтетический what-if»</a:t>
+            </a:r>
+          </a:p>
+        </p:txBody>
+      </p:sp>
+      <p:sp>
+        <p:nvSpPr>
+          <p:cNvPr id="8" name="">
+            <a:extLst xmlns:a="http://schemas.openxmlformats.org/drawingml/2006/main">
+              <a:ext uri="{FF2B5EF4-FFF2-40B4-BE49-F238E27FC236}">
+                <a16:creationId xmlns:a16="http://schemas.microsoft.com/office/drawing/2014/main" id="{F996ACCD-EFFC-470B-B867-4CD84983EF6A}"/>
+              </a:ext>
+            </a:extLst>
+          </p:cNvPr>
+          <p:cNvSpPr>
+            <a:spLocks xmlns:a="http://schemas.openxmlformats.org/drawingml/2006/main" noGrp="1"/>
+          </p:cNvSpPr>
+          <p:nvPr/>
+        </p:nvSpPr>
+        <p:spPr>
+          <a:xfrm xmlns:a="http://schemas.openxmlformats.org/drawingml/2006/main">
+            <a:off x="6858000" y="3790950"/>
+            <a:ext cx="4667250" cy="457200"/>
+          </a:xfrm>
+          <a:prstGeom xmlns:a="http://schemas.openxmlformats.org/drawingml/2006/main" prst="rect">
+            <a:avLst/>
+          </a:prstGeom>
+          <a:noFill xmlns:a="http://schemas.openxmlformats.org/drawingml/2006/main"/>
+          <a:ln xmlns:a="http://schemas.openxmlformats.org/drawingml/2006/main" w="0">
+            <a:noFill/>
+          </a:ln>
+        </p:spPr>
+        <p:txBody>
+          <a:bodyPr xmlns:a="http://schemas.openxmlformats.org/drawingml/2006/main" anchor="t">
+            <a:noAutofit/>
+          </a:bodyPr>
+          <a:lstStyle xmlns:a="http://schemas.openxmlformats.org/drawingml/2006/main"/>
+          <a:p xmlns:a="http://schemas.openxmlformats.org/drawingml/2006/main">
+            <a:pPr>
+              <a:defRPr sz="2250" b="1">
+                <a:solidFill>
+                  <a:srgbClr val="007F7B"/>
+                </a:solidFill>
+                <a:latin typeface="Arial"/>
+                <a:ea typeface="Arial"/>
+                <a:cs typeface="Arial"/>
+              </a:defRPr>
+            </a:pPr>
+            <a:r>
+              <a:rPr sz="2250" b="1">
+                <a:solidFill>
+                  <a:srgbClr val="007F7B"/>
+                </a:solidFill>
+                <a:latin typeface="Arial"/>
+                <a:ea typeface="Arial"/>
+                <a:cs typeface="Arial"/>
+              </a:rPr>
+              <a:t>2. Изменить и пересчитать</a:t>
+            </a:r>
+          </a:p>
+        </p:txBody>
+      </p:sp>
+      <p:sp>
+        <p:nvSpPr>
+          <p:cNvPr id="9" name="">
+            <a:extLst xmlns:a="http://schemas.openxmlformats.org/drawingml/2006/main">
+              <a:ext uri="{FF2B5EF4-FFF2-40B4-BE49-F238E27FC236}">
+                <a16:creationId xmlns:a16="http://schemas.microsoft.com/office/drawing/2014/main" id="{9EB9DE5E-DD77-4E68-B049-146C143776DA}"/>
+              </a:ext>
+            </a:extLst>
+          </p:cNvPr>
+          <p:cNvSpPr>
+            <a:spLocks xmlns:a="http://schemas.openxmlformats.org/drawingml/2006/main" noGrp="1"/>
+          </p:cNvSpPr>
+          <p:nvPr/>
+        </p:nvSpPr>
+        <p:spPr>
+          <a:xfrm xmlns:a="http://schemas.openxmlformats.org/drawingml/2006/main">
+            <a:off x="6858000" y="4333875"/>
+            <a:ext cx="4667250" cy="819150"/>
+          </a:xfrm>
+          <a:prstGeom xmlns:a="http://schemas.openxmlformats.org/drawingml/2006/main" prst="rect">
+            <a:avLst/>
+          </a:prstGeom>
+          <a:noFill xmlns:a="http://schemas.openxmlformats.org/drawingml/2006/main"/>
+          <a:ln xmlns:a="http://schemas.openxmlformats.org/drawingml/2006/main" w="0">
+            <a:noFill/>
+          </a:ln>
+        </p:spPr>
+        <p:txBody>
+          <a:bodyPr xmlns:a="http://schemas.openxmlformats.org/drawingml/2006/main" anchor="t">
+            <a:noAutofit/>
+          </a:bodyPr>
+          <a:lstStyle xmlns:a="http://schemas.openxmlformats.org/drawingml/2006/main"/>
+          <a:p xmlns:a="http://schemas.openxmlformats.org/drawingml/2006/main">
+            <a:pPr>
+              <a:defRPr sz="2025" b="0">
+                <a:solidFill>
+                  <a:srgbClr val="14252C"/>
+                </a:solidFill>
+                <a:latin typeface="Arial"/>
+                <a:ea typeface="Arial"/>
+                <a:cs typeface="Arial"/>
+              </a:defRPr>
+            </a:pPr>
+            <a:r>
+              <a:rPr sz="2025" b="0">
+                <a:solidFill>
+                  <a:srgbClr val="14252C"/>
+                </a:solidFill>
+                <a:latin typeface="Arial"/>
+                <a:ea typeface="Arial"/>
+                <a:cs typeface="Arial"/>
+              </a:rPr>
+              <a:t>Свойства, запасы, доли,</a:t>
+            </a:r>
+          </a:p>
+          <a:p xmlns:a="http://schemas.openxmlformats.org/drawingml/2006/main">
+            <a:pPr>
+              <a:defRPr sz="2025" b="0">
+                <a:solidFill>
+                  <a:srgbClr val="14252C"/>
+                </a:solidFill>
+                <a:latin typeface="Arial"/>
+                <a:ea typeface="Arial"/>
+                <a:cs typeface="Arial"/>
+              </a:defRPr>
+            </a:pPr>
+            <a:r>
+              <a:rPr sz="2025" b="0">
+                <a:solidFill>
+                  <a:srgbClr val="14252C"/>
+                </a:solidFill>
+                <a:latin typeface="Arial"/>
+                <a:ea typeface="Arial"/>
+                <a:cs typeface="Arial"/>
+              </a:rPr>
+              <a:t>партия и эффект присадки.</a:t>
+            </a:r>
+          </a:p>
+        </p:txBody>
+      </p:sp>
+      <p:sp>
+        <p:nvSpPr>
+          <p:cNvPr id="10" name="">
+            <a:extLst xmlns:a="http://schemas.openxmlformats.org/drawingml/2006/main">
+              <a:ext uri="{FF2B5EF4-FFF2-40B4-BE49-F238E27FC236}">
+                <a16:creationId xmlns:a16="http://schemas.microsoft.com/office/drawing/2014/main" id="{D13C3F9A-656D-40BC-8340-077C59268D73}"/>
+              </a:ext>
+            </a:extLst>
+          </p:cNvPr>
+          <p:cNvSpPr>
+            <a:spLocks xmlns:a="http://schemas.openxmlformats.org/drawingml/2006/main" noGrp="1"/>
+          </p:cNvSpPr>
+          <p:nvPr/>
+        </p:nvSpPr>
+        <p:spPr>
+          <a:xfrm xmlns:a="http://schemas.openxmlformats.org/drawingml/2006/main">
+            <a:off x="6858000" y="5419725"/>
+            <a:ext cx="4667250" cy="428625"/>
+          </a:xfrm>
+          <a:prstGeom xmlns:a="http://schemas.openxmlformats.org/drawingml/2006/main" prst="rect">
+            <a:avLst/>
+          </a:prstGeom>
+          <a:noFill xmlns:a="http://schemas.openxmlformats.org/drawingml/2006/main"/>
+          <a:ln xmlns:a="http://schemas.openxmlformats.org/drawingml/2006/main" w="0">
+            <a:noFill/>
+          </a:ln>
+        </p:spPr>
+        <p:txBody>
+          <a:bodyPr xmlns:a="http://schemas.openxmlformats.org/drawingml/2006/main" anchor="t">
+            <a:noAutofit/>
+          </a:bodyPr>
+          <a:lstStyle xmlns:a="http://schemas.openxmlformats.org/drawingml/2006/main"/>
+          <a:p xmlns:a="http://schemas.openxmlformats.org/drawingml/2006/main">
+            <a:pPr>
+              <a:defRPr sz="2250" b="1">
+                <a:solidFill>
+                  <a:srgbClr val="007F7B"/>
+                </a:solidFill>
+                <a:latin typeface="Arial"/>
+                <a:ea typeface="Arial"/>
+                <a:cs typeface="Arial"/>
+              </a:defRPr>
+            </a:pPr>
+            <a:r>
+              <a:rPr sz="2250" b="1">
+                <a:solidFill>
+                  <a:srgbClr val="007F7B"/>
+                </a:solidFill>
+                <a:latin typeface="Arial"/>
+                <a:ea typeface="Arial"/>
+                <a:cs typeface="Arial"/>
+              </a:rPr>
+              <a:t>3. Сбросить к сценарию</a:t>
+            </a:r>
+          </a:p>
+        </p:txBody>
+      </p:sp>
+      <p:sp>
+        <p:nvSpPr>
+          <p:cNvPr id="11" name="">
+            <a:extLst xmlns:a="http://schemas.openxmlformats.org/drawingml/2006/main">
+              <a:ext uri="{FF2B5EF4-FFF2-40B4-BE49-F238E27FC236}">
+                <a16:creationId xmlns:a16="http://schemas.microsoft.com/office/drawing/2014/main" id="{478B54F7-413F-4B67-9D5F-B6591C158D95}"/>
+              </a:ext>
+            </a:extLst>
+          </p:cNvPr>
+          <p:cNvSpPr>
+            <a:spLocks xmlns:a="http://schemas.openxmlformats.org/drawingml/2006/main" noGrp="1"/>
+          </p:cNvSpPr>
+          <p:nvPr/>
+        </p:nvSpPr>
+        <p:spPr>
+          <a:xfrm xmlns:a="http://schemas.openxmlformats.org/drawingml/2006/main">
+            <a:off x="6858000" y="5905500"/>
+            <a:ext cx="4667250" cy="400050"/>
+          </a:xfrm>
+          <a:prstGeom xmlns:a="http://schemas.openxmlformats.org/drawingml/2006/main" prst="rect">
+            <a:avLst/>
+          </a:prstGeom>
+          <a:noFill xmlns:a="http://schemas.openxmlformats.org/drawingml/2006/main"/>
+          <a:ln xmlns:a="http://schemas.openxmlformats.org/drawingml/2006/main" w="0">
+            <a:noFill/>
+          </a:ln>
+        </p:spPr>
+        <p:txBody>
+          <a:bodyPr xmlns:a="http://schemas.openxmlformats.org/drawingml/2006/main" anchor="t">
+            <a:noAutofit/>
+          </a:bodyPr>
+          <a:lstStyle xmlns:a="http://schemas.openxmlformats.org/drawingml/2006/main"/>
+          <a:p xmlns:a="http://schemas.openxmlformats.org/drawingml/2006/main">
+            <a:pPr>
+              <a:defRPr sz="1875" b="0">
+                <a:solidFill>
+                  <a:srgbClr val="586C73"/>
+                </a:solidFill>
+                <a:latin typeface="Arial"/>
+                <a:ea typeface="Arial"/>
+                <a:cs typeface="Arial"/>
+              </a:defRPr>
+            </a:pPr>
+            <a:r>
+              <a:rPr sz="1875" b="0">
+                <a:solidFill>
+                  <a:srgbClr val="586C73"/>
+                </a:solidFill>
+                <a:latin typeface="Arial"/>
+                <a:ea typeface="Arial"/>
+                <a:cs typeface="Arial"/>
+              </a:rPr>
+              <a:t>Затем снова нажать пересчёт.</a:t>
+            </a:r>
+          </a:p>
+        </p:txBody>
+      </p:sp>
+    </p:spTree>
+    <p:extLst>
+      <p:ext uri="{BB962C8B-B14F-4D97-AF65-F5344CB8AC3E}">
+        <p14:creationId xmlns:p14="http://schemas.microsoft.com/office/powerpoint/2010/main" val="1183795989"/>
+      </p:ext>
+    </p:extLst>
+  </p:cSld>
+</p:sld>
+</file>
+
+<file path=ppt/slides/slide13.xml><?xml version="1.0" encoding="utf-8"?>
+<p:sld xmlns:p="http://schemas.openxmlformats.org/presentationml/2006/main">
+  <p:cSld>
+    <p:bg>
+      <p:bgPr>
+        <a:solidFill xmlns:a="http://schemas.openxmlformats.org/drawingml/2006/main">
+          <a:srgbClr val="F2F3EF"/>
+        </a:solidFill>
+      </p:bgPr>
+    </p:bg>
+    <p:spTree>
+      <p:nvGrpSpPr>
+        <p:cNvPr id="1" name=""/>
+        <p:cNvGrpSpPr/>
+        <p:nvPr/>
+      </p:nvGrpSpPr>
+      <p:grpSpPr>
+        <a:xfrm xmlns:a="http://schemas.openxmlformats.org/drawingml/2006/main"/>
+      </p:grpSpPr>
+      <p:sp>
+        <p:nvSpPr>
+          <p:cNvPr id="10" name="">
+            <a:extLst xmlns:a="http://schemas.openxmlformats.org/drawingml/2006/main">
+              <a:ext uri="{FF2B5EF4-FFF2-40B4-BE49-F238E27FC236}">
+                <a16:creationId xmlns:a16="http://schemas.microsoft.com/office/drawing/2014/main" id="{685676C3-AB63-4D0C-A97D-018459C888C3}"/>
+              </a:ext>
+            </a:extLst>
+          </p:cNvPr>
+          <p:cNvSpPr>
+            <a:spLocks xmlns:a="http://schemas.openxmlformats.org/drawingml/2006/main" noGrp="1"/>
+          </p:cNvSpPr>
+          <p:nvPr/>
+        </p:nvSpPr>
+        <p:spPr>
+          <a:xfrm xmlns:a="http://schemas.openxmlformats.org/drawingml/2006/main">
+            <a:off x="609600" y="304800"/>
+            <a:ext cx="9525000" cy="266700"/>
+          </a:xfrm>
+          <a:prstGeom xmlns:a="http://schemas.openxmlformats.org/drawingml/2006/main" prst="rect">
+            <a:avLst/>
+          </a:prstGeom>
+          <a:noFill xmlns:a="http://schemas.openxmlformats.org/drawingml/2006/main"/>
+          <a:ln xmlns:a="http://schemas.openxmlformats.org/drawingml/2006/main" w="0">
+            <a:noFill/>
+          </a:ln>
+        </p:spPr>
+        <p:txBody>
+          <a:bodyPr xmlns:a="http://schemas.openxmlformats.org/drawingml/2006/main" anchor="t">
+            <a:noAutofit/>
+          </a:bodyPr>
+          <a:lstStyle xmlns:a="http://schemas.openxmlformats.org/drawingml/2006/main"/>
+          <a:p xmlns:a="http://schemas.openxmlformats.org/drawingml/2006/main">
+            <a:pPr>
+              <a:defRPr sz="1200" b="1">
+                <a:solidFill>
+                  <a:srgbClr val="007F7B"/>
+                </a:solidFill>
+                <a:latin typeface="Arial"/>
+                <a:ea typeface="Arial"/>
+                <a:cs typeface="Arial"/>
+              </a:defRPr>
+            </a:pPr>
+            <a:r>
+              <a:rPr sz="1200" b="1">
+                <a:solidFill>
+                  <a:srgbClr val="007F7B"/>
+                </a:solidFill>
+                <a:latin typeface="Arial"/>
+                <a:ea typeface="Arial"/>
+                <a:cs typeface="Arial"/>
+              </a:rPr>
+              <a:t>НОВОЕ В v1.1.0</a:t>
+            </a:r>
+          </a:p>
+        </p:txBody>
+      </p:sp>
+      <p:sp>
+        <p:nvSpPr>
+          <p:cNvPr id="2" name="">
+            <a:extLst xmlns:a="http://schemas.openxmlformats.org/drawingml/2006/main">
+              <a:ext uri="{FF2B5EF4-FFF2-40B4-BE49-F238E27FC236}">
+                <a16:creationId xmlns:a16="http://schemas.microsoft.com/office/drawing/2014/main" id="{A1CED077-42F9-4C54-8A8D-97AC1133563A}"/>
+              </a:ext>
+            </a:extLst>
+          </p:cNvPr>
+          <p:cNvSpPr>
+            <a:spLocks xmlns:a="http://schemas.openxmlformats.org/drawingml/2006/main" noGrp="1"/>
+          </p:cNvSpPr>
+          <p:nvPr/>
+        </p:nvSpPr>
+        <p:spPr>
+          <a:xfrm xmlns:a="http://schemas.openxmlformats.org/drawingml/2006/main">
+            <a:off x="609600" y="790575"/>
+            <a:ext cx="10972800" cy="1066800"/>
+          </a:xfrm>
+          <a:prstGeom xmlns:a="http://schemas.openxmlformats.org/drawingml/2006/main" prst="rect">
+            <a:avLst/>
+          </a:prstGeom>
+          <a:noFill xmlns:a="http://schemas.openxmlformats.org/drawingml/2006/main"/>
+          <a:ln xmlns:a="http://schemas.openxmlformats.org/drawingml/2006/main" w="0">
+            <a:noFill/>
+          </a:ln>
+        </p:spPr>
+        <p:txBody>
+          <a:bodyPr xmlns:a="http://schemas.openxmlformats.org/drawingml/2006/main" anchor="t">
+            <a:noAutofit/>
+          </a:bodyPr>
+          <a:lstStyle xmlns:a="http://schemas.openxmlformats.org/drawingml/2006/main"/>
+          <a:p xmlns:a="http://schemas.openxmlformats.org/drawingml/2006/main">
+            <a:pPr>
+              <a:defRPr sz="3450" b="1">
+                <a:solidFill>
+                  <a:srgbClr val="14252C"/>
+                </a:solidFill>
+                <a:latin typeface="Arial"/>
+                <a:ea typeface="Arial"/>
+                <a:cs typeface="Arial"/>
+              </a:defRPr>
+            </a:pPr>
+            <a:r>
+              <a:rPr sz="3450" b="1">
+                <a:solidFill>
+                  <a:srgbClr val="14252C"/>
+                </a:solidFill>
+                <a:latin typeface="Arial"/>
+                <a:ea typeface="Arial"/>
+                <a:cs typeface="Arial"/>
+              </a:rPr>
+              <a:t>Исторический прогноз на графике</a:t>
+            </a:r>
+          </a:p>
+        </p:txBody>
+      </p:sp>
+      <p:sp>
+        <p:nvSpPr>
+          <p:cNvPr id="3" name="">
+            <a:extLst xmlns:a="http://schemas.openxmlformats.org/drawingml/2006/main">
+              <a:ext uri="{FF2B5EF4-FFF2-40B4-BE49-F238E27FC236}">
+                <a16:creationId xmlns:a16="http://schemas.microsoft.com/office/drawing/2014/main" id="{2C2590C7-0B60-46D8-A5D8-1CB23AED60D1}"/>
+              </a:ext>
+            </a:extLst>
+          </p:cNvPr>
+          <p:cNvSpPr>
+            <a:spLocks xmlns:a="http://schemas.openxmlformats.org/drawingml/2006/main" noGrp="1"/>
+          </p:cNvSpPr>
+          <p:nvPr/>
+        </p:nvSpPr>
+        <p:spPr>
+          <a:xfrm xmlns:a="http://schemas.openxmlformats.org/drawingml/2006/main">
+            <a:off x="609600" y="6438900"/>
+            <a:ext cx="9906000" cy="209550"/>
+          </a:xfrm>
+          <a:prstGeom xmlns:a="http://schemas.openxmlformats.org/drawingml/2006/main" prst="rect">
+            <a:avLst/>
+          </a:prstGeom>
+          <a:noFill xmlns:a="http://schemas.openxmlformats.org/drawingml/2006/main"/>
+          <a:ln xmlns:a="http://schemas.openxmlformats.org/drawingml/2006/main" w="0">
+            <a:noFill/>
+          </a:ln>
+        </p:spPr>
+        <p:txBody>
+          <a:bodyPr xmlns:a="http://schemas.openxmlformats.org/drawingml/2006/main" anchor="t">
+            <a:noAutofit/>
+          </a:bodyPr>
+          <a:lstStyle xmlns:a="http://schemas.openxmlformats.org/drawingml/2006/main"/>
+          <a:p xmlns:a="http://schemas.openxmlformats.org/drawingml/2006/main">
+            <a:pPr>
+              <a:defRPr sz="975" b="0">
+                <a:solidFill>
+                  <a:srgbClr val="586C73"/>
+                </a:solidFill>
+                <a:latin typeface="Arial"/>
+                <a:ea typeface="Arial"/>
+                <a:cs typeface="Arial"/>
+              </a:defRPr>
+            </a:pPr>
+            <a:r>
+              <a:rPr sz="975" b="0">
+                <a:solidFill>
+                  <a:srgbClr val="586C73"/>
+                </a:solidFill>
+                <a:latin typeface="Arial"/>
+                <a:ea typeface="Arial"/>
+                <a:cs typeface="Arial"/>
+              </a:rPr>
+              <a:t>НЕФТЕКОД 2.0  /  СИСТЕМА ПОДДЕРЖКИ РЕШЕНИЙ</a:t>
+            </a:r>
+          </a:p>
+        </p:txBody>
+      </p:sp>
+      <p:sp>
+        <p:nvSpPr>
+          <p:cNvPr id="4" name="">
+            <a:extLst xmlns:a="http://schemas.openxmlformats.org/drawingml/2006/main">
+              <a:ext uri="{FF2B5EF4-FFF2-40B4-BE49-F238E27FC236}">
+                <a16:creationId xmlns:a16="http://schemas.microsoft.com/office/drawing/2014/main" id="{A56AC05E-9910-45AB-836E-50437D4B7165}"/>
+              </a:ext>
+            </a:extLst>
+          </p:cNvPr>
+          <p:cNvSpPr>
+            <a:spLocks xmlns:a="http://schemas.openxmlformats.org/drawingml/2006/main" noGrp="1"/>
+          </p:cNvSpPr>
+          <p:nvPr/>
+        </p:nvSpPr>
+        <p:spPr>
+          <a:xfrm xmlns:a="http://schemas.openxmlformats.org/drawingml/2006/main">
+            <a:off x="11153775" y="6410325"/>
+            <a:ext cx="523875" cy="257175"/>
+          </a:xfrm>
+          <a:prstGeom xmlns:a="http://schemas.openxmlformats.org/drawingml/2006/main" prst="rect">
+            <a:avLst/>
+          </a:prstGeom>
+          <a:noFill xmlns:a="http://schemas.openxmlformats.org/drawingml/2006/main"/>
+          <a:ln xmlns:a="http://schemas.openxmlformats.org/drawingml/2006/main" w="0">
+            <a:noFill/>
+          </a:ln>
+        </p:spPr>
+        <p:txBody>
+          <a:bodyPr xmlns:a="http://schemas.openxmlformats.org/drawingml/2006/main" anchor="t">
+            <a:noAutofit/>
+          </a:bodyPr>
+          <a:lstStyle xmlns:a="http://schemas.openxmlformats.org/drawingml/2006/main"/>
+          <a:p xmlns:a="http://schemas.openxmlformats.org/drawingml/2006/main">
+            <a:pPr>
+              <a:defRPr sz="1350" b="1">
+                <a:solidFill>
+                  <a:srgbClr val="007F7B"/>
+                </a:solidFill>
+                <a:latin typeface="Arial"/>
+                <a:ea typeface="Arial"/>
+                <a:cs typeface="Arial"/>
+              </a:defRPr>
+            </a:pPr>
+            <a:r>
+              <a:rPr sz="1350" b="1">
+                <a:solidFill>
+                  <a:srgbClr val="007F7B"/>
+                </a:solidFill>
+                <a:latin typeface="Arial"/>
+                <a:ea typeface="Arial"/>
+                <a:cs typeface="Arial"/>
+              </a:rPr>
+              <a:t>13</a:t>
+            </a:r>
+          </a:p>
+        </p:txBody>
+      </p:sp>
+      <p:pic>
+        <p:nvPicPr>
+          <p:cNvPr id="14" name=""/>
+          <p:cNvPicPr>
+            <a:picLocks xmlns:a="http://schemas.openxmlformats.org/drawingml/2006/main" noChangeAspect="1"/>
+          </p:cNvPicPr>
+          <p:nvPr/>
+        </p:nvPicPr>
+        <p:blipFill>
+          <a:blip xmlns:r="http://schemas.openxmlformats.org/officeDocument/2006/relationships" xmlns:a="http://schemas.openxmlformats.org/drawingml/2006/main" r:embed="Rb8d58a9bb51d4d43"/>
+          <a:stretch xmlns:a="http://schemas.openxmlformats.org/drawingml/2006/main"/>
+        </p:blipFill>
+        <p:spPr>
+          <a:xfrm xmlns:a="http://schemas.openxmlformats.org/drawingml/2006/main">
+            <a:off x="645288" y="1876425"/>
+            <a:ext cx="7215249" cy="4400550"/>
+          </a:xfrm>
+          <a:prstGeom xmlns:a="http://schemas.openxmlformats.org/drawingml/2006/main" prst="rect">
+            <a:avLst/>
+          </a:prstGeom>
+        </p:spPr>
+      </p:pic>
+      <p:sp>
+        <p:nvSpPr>
+          <p:cNvPr id="6" name="">
+            <a:extLst xmlns:a="http://schemas.openxmlformats.org/drawingml/2006/main">
+              <a:ext uri="{FF2B5EF4-FFF2-40B4-BE49-F238E27FC236}">
+                <a16:creationId xmlns:a16="http://schemas.microsoft.com/office/drawing/2014/main" id="{A303F623-0F1B-4B95-BFC4-CC624F97D3FB}"/>
+              </a:ext>
+            </a:extLst>
+          </p:cNvPr>
+          <p:cNvSpPr>
+            <a:spLocks xmlns:a="http://schemas.openxmlformats.org/drawingml/2006/main" noGrp="1"/>
+          </p:cNvSpPr>
+          <p:nvPr/>
+        </p:nvSpPr>
+        <p:spPr>
+          <a:xfrm xmlns:a="http://schemas.openxmlformats.org/drawingml/2006/main">
+            <a:off x="8258175" y="2238375"/>
+            <a:ext cx="3333750" cy="466725"/>
+          </a:xfrm>
+          <a:prstGeom xmlns:a="http://schemas.openxmlformats.org/drawingml/2006/main" prst="rect">
+            <a:avLst/>
+          </a:prstGeom>
+          <a:noFill xmlns:a="http://schemas.openxmlformats.org/drawingml/2006/main"/>
+          <a:ln xmlns:a="http://schemas.openxmlformats.org/drawingml/2006/main" w="0">
+            <a:noFill/>
+          </a:ln>
+        </p:spPr>
+        <p:txBody>
+          <a:bodyPr xmlns:a="http://schemas.openxmlformats.org/drawingml/2006/main" anchor="t">
+            <a:noAutofit/>
+          </a:bodyPr>
+          <a:lstStyle xmlns:a="http://schemas.openxmlformats.org/drawingml/2006/main"/>
+          <a:p xmlns:a="http://schemas.openxmlformats.org/drawingml/2006/main">
+            <a:pPr>
+              <a:defRPr sz="2250" b="1">
+                <a:solidFill>
+                  <a:srgbClr val="007F7B"/>
+                </a:solidFill>
+                <a:latin typeface="Arial"/>
+                <a:ea typeface="Arial"/>
+                <a:cs typeface="Arial"/>
+              </a:defRPr>
+            </a:pPr>
+            <a:r>
+              <a:rPr sz="2250" b="1">
+                <a:solidFill>
+                  <a:srgbClr val="007F7B"/>
+                </a:solidFill>
+                <a:latin typeface="Arial"/>
+                <a:ea typeface="Arial"/>
+                <a:cs typeface="Arial"/>
+              </a:rPr>
+              <a:t>Выбрать период</a:t>
+            </a:r>
+          </a:p>
+        </p:txBody>
+      </p:sp>
+      <p:sp>
+        <p:nvSpPr>
+          <p:cNvPr id="7" name="">
+            <a:extLst xmlns:a="http://schemas.openxmlformats.org/drawingml/2006/main">
+              <a:ext uri="{FF2B5EF4-FFF2-40B4-BE49-F238E27FC236}">
+                <a16:creationId xmlns:a16="http://schemas.microsoft.com/office/drawing/2014/main" id="{F568DBB6-4779-43C0-B308-29D3CE21AE60}"/>
+              </a:ext>
+            </a:extLst>
+          </p:cNvPr>
+          <p:cNvSpPr>
+            <a:spLocks xmlns:a="http://schemas.openxmlformats.org/drawingml/2006/main" noGrp="1"/>
+          </p:cNvSpPr>
+          <p:nvPr/>
+        </p:nvSpPr>
+        <p:spPr>
+          <a:xfrm xmlns:a="http://schemas.openxmlformats.org/drawingml/2006/main">
+            <a:off x="8258175" y="2886075"/>
+            <a:ext cx="3333750" cy="1381125"/>
+          </a:xfrm>
+          <a:prstGeom xmlns:a="http://schemas.openxmlformats.org/drawingml/2006/main" prst="rect">
+            <a:avLst/>
+          </a:prstGeom>
+          <a:noFill xmlns:a="http://schemas.openxmlformats.org/drawingml/2006/main"/>
+          <a:ln xmlns:a="http://schemas.openxmlformats.org/drawingml/2006/main" w="0">
+            <a:noFill/>
+          </a:ln>
+        </p:spPr>
+        <p:txBody>
+          <a:bodyPr xmlns:a="http://schemas.openxmlformats.org/drawingml/2006/main" anchor="t">
+            <a:noAutofit/>
+          </a:bodyPr>
+          <a:lstStyle xmlns:a="http://schemas.openxmlformats.org/drawingml/2006/main"/>
+          <a:p xmlns:a="http://schemas.openxmlformats.org/drawingml/2006/main">
+            <a:pPr>
+              <a:defRPr sz="2100" b="0">
+                <a:solidFill>
+                  <a:srgbClr val="14252C"/>
+                </a:solidFill>
+                <a:latin typeface="Arial"/>
+                <a:ea typeface="Arial"/>
+                <a:cs typeface="Arial"/>
+              </a:defRPr>
+            </a:pPr>
+            <a:r>
+              <a:rPr sz="2100" b="0">
+                <a:solidFill>
+                  <a:srgbClr val="14252C"/>
+                </a:solidFill>
+                <a:latin typeface="Arial"/>
+                <a:ea typeface="Arial"/>
+                <a:cs typeface="Arial"/>
+              </a:rPr>
+              <a:t>Прогноз, верхняя</a:t>
+            </a:r>
+          </a:p>
+          <a:p xmlns:a="http://schemas.openxmlformats.org/drawingml/2006/main">
+            <a:pPr>
+              <a:defRPr sz="2100" b="0">
+                <a:solidFill>
+                  <a:srgbClr val="14252C"/>
+                </a:solidFill>
+                <a:latin typeface="Arial"/>
+                <a:ea typeface="Arial"/>
+                <a:cs typeface="Arial"/>
+              </a:defRPr>
+            </a:pPr>
+            <a:r>
+              <a:rPr sz="2100" b="0">
+                <a:solidFill>
+                  <a:srgbClr val="14252C"/>
+                </a:solidFill>
+                <a:latin typeface="Arial"/>
+                <a:ea typeface="Arial"/>
+                <a:cs typeface="Arial"/>
+              </a:rPr>
+              <a:t>оценка и предел</a:t>
+            </a:r>
+          </a:p>
+          <a:p xmlns:a="http://schemas.openxmlformats.org/drawingml/2006/main">
+            <a:pPr>
+              <a:defRPr sz="2100" b="0">
+                <a:solidFill>
+                  <a:srgbClr val="14252C"/>
+                </a:solidFill>
+                <a:latin typeface="Arial"/>
+                <a:ea typeface="Arial"/>
+                <a:cs typeface="Arial"/>
+              </a:defRPr>
+            </a:pPr>
+            <a:r>
+              <a:rPr sz="2100" b="0">
+                <a:solidFill>
+                  <a:srgbClr val="14252C"/>
+                </a:solidFill>
+                <a:latin typeface="Arial"/>
+                <a:ea typeface="Arial"/>
+                <a:cs typeface="Arial"/>
+              </a:rPr>
+              <a:t>10 мг/кг.</a:t>
+            </a:r>
+          </a:p>
+        </p:txBody>
+      </p:sp>
+      <p:sp>
+        <p:nvSpPr>
+          <p:cNvPr id="8" name="">
+            <a:extLst xmlns:a="http://schemas.openxmlformats.org/drawingml/2006/main">
+              <a:ext uri="{FF2B5EF4-FFF2-40B4-BE49-F238E27FC236}">
+                <a16:creationId xmlns:a16="http://schemas.microsoft.com/office/drawing/2014/main" id="{732093FF-E1A5-438C-B427-BE9BFD767B2B}"/>
+              </a:ext>
+            </a:extLst>
+          </p:cNvPr>
+          <p:cNvSpPr>
+            <a:spLocks xmlns:a="http://schemas.openxmlformats.org/drawingml/2006/main" noGrp="1"/>
+          </p:cNvSpPr>
+          <p:nvPr/>
+        </p:nvSpPr>
+        <p:spPr>
+          <a:xfrm xmlns:a="http://schemas.openxmlformats.org/drawingml/2006/main">
+            <a:off x="8258175" y="4476750"/>
+            <a:ext cx="3333750" cy="1190625"/>
+          </a:xfrm>
+          <a:prstGeom xmlns:a="http://schemas.openxmlformats.org/drawingml/2006/main" prst="rect">
+            <a:avLst/>
+          </a:prstGeom>
+          <a:noFill xmlns:a="http://schemas.openxmlformats.org/drawingml/2006/main"/>
+          <a:ln xmlns:a="http://schemas.openxmlformats.org/drawingml/2006/main" w="0">
+            <a:noFill/>
+          </a:ln>
+        </p:spPr>
+        <p:txBody>
+          <a:bodyPr xmlns:a="http://schemas.openxmlformats.org/drawingml/2006/main" anchor="t">
+            <a:noAutofit/>
+          </a:bodyPr>
+          <a:lstStyle xmlns:a="http://schemas.openxmlformats.org/drawingml/2006/main"/>
+          <a:p xmlns:a="http://schemas.openxmlformats.org/drawingml/2006/main">
+            <a:pPr>
+              <a:defRPr sz="1950" b="0">
+                <a:solidFill>
+                  <a:srgbClr val="586C73"/>
+                </a:solidFill>
+                <a:latin typeface="Arial"/>
+                <a:ea typeface="Arial"/>
+                <a:cs typeface="Arial"/>
+              </a:defRPr>
+            </a:pPr>
+            <a:r>
+              <a:rPr sz="1950" b="0">
+                <a:solidFill>
+                  <a:srgbClr val="586C73"/>
+                </a:solidFill>
+                <a:latin typeface="Arial"/>
+                <a:ea typeface="Arial"/>
+                <a:cs typeface="Arial"/>
+              </a:rPr>
+              <a:t>Пути данных и модели</a:t>
+            </a:r>
+          </a:p>
+          <a:p xmlns:a="http://schemas.openxmlformats.org/drawingml/2006/main">
+            <a:pPr>
+              <a:defRPr sz="1950" b="0">
+                <a:solidFill>
+                  <a:srgbClr val="586C73"/>
+                </a:solidFill>
+                <a:latin typeface="Arial"/>
+                <a:ea typeface="Arial"/>
+                <a:cs typeface="Arial"/>
+              </a:defRPr>
+            </a:pPr>
+            <a:r>
+              <a:rPr sz="1950" b="0">
+                <a:solidFill>
+                  <a:srgbClr val="586C73"/>
+                </a:solidFill>
+                <a:latin typeface="Arial"/>
+                <a:ea typeface="Arial"/>
+                <a:cs typeface="Arial"/>
+              </a:rPr>
+              <a:t>в дополнительных</a:t>
+            </a:r>
+          </a:p>
+          <a:p xmlns:a="http://schemas.openxmlformats.org/drawingml/2006/main">
+            <a:pPr>
+              <a:defRPr sz="1950" b="0">
+                <a:solidFill>
+                  <a:srgbClr val="586C73"/>
+                </a:solidFill>
+                <a:latin typeface="Arial"/>
+                <a:ea typeface="Arial"/>
+                <a:cs typeface="Arial"/>
+              </a:defRPr>
+            </a:pPr>
+            <a:r>
+              <a:rPr sz="1950" b="0">
+                <a:solidFill>
+                  <a:srgbClr val="586C73"/>
+                </a:solidFill>
+                <a:latin typeface="Arial"/>
+                <a:ea typeface="Arial"/>
+                <a:cs typeface="Arial"/>
+              </a:rPr>
+              <a:t>настройках.</a:t>
+            </a:r>
+          </a:p>
+        </p:txBody>
+      </p:sp>
+      <p:sp>
+        <p:nvSpPr>
+          <p:cNvPr id="9" name="">
+            <a:extLst xmlns:a="http://schemas.openxmlformats.org/drawingml/2006/main">
+              <a:ext uri="{FF2B5EF4-FFF2-40B4-BE49-F238E27FC236}">
+                <a16:creationId xmlns:a16="http://schemas.microsoft.com/office/drawing/2014/main" id="{3B163A1A-22FA-48AB-B58D-956EF3276F15}"/>
+              </a:ext>
+            </a:extLst>
+          </p:cNvPr>
+          <p:cNvSpPr>
+            <a:spLocks xmlns:a="http://schemas.openxmlformats.org/drawingml/2006/main" noGrp="1"/>
+          </p:cNvSpPr>
+          <p:nvPr/>
+        </p:nvSpPr>
+        <p:spPr>
+          <a:xfrm xmlns:a="http://schemas.openxmlformats.org/drawingml/2006/main">
+            <a:off x="8258175" y="5829300"/>
+            <a:ext cx="3333750" cy="400050"/>
+          </a:xfrm>
+          <a:prstGeom xmlns:a="http://schemas.openxmlformats.org/drawingml/2006/main" prst="rect">
+            <a:avLst/>
+          </a:prstGeom>
+          <a:noFill xmlns:a="http://schemas.openxmlformats.org/drawingml/2006/main"/>
+          <a:ln xmlns:a="http://schemas.openxmlformats.org/drawingml/2006/main" w="0">
+            <a:noFill/>
+          </a:ln>
+        </p:spPr>
+        <p:txBody>
+          <a:bodyPr xmlns:a="http://schemas.openxmlformats.org/drawingml/2006/main" anchor="t">
+            <a:noAutofit/>
+          </a:bodyPr>
+          <a:lstStyle xmlns:a="http://schemas.openxmlformats.org/drawingml/2006/main"/>
+          <a:p xmlns:a="http://schemas.openxmlformats.org/drawingml/2006/main">
+            <a:pPr>
+              <a:defRPr sz="1725" b="0">
+                <a:solidFill>
+                  <a:srgbClr val="586C73"/>
+                </a:solidFill>
+                <a:latin typeface="Arial"/>
+                <a:ea typeface="Arial"/>
+                <a:cs typeface="Arial"/>
+              </a:defRPr>
+            </a:pPr>
+            <a:r>
+              <a:rPr sz="1725" b="0">
+                <a:solidFill>
+                  <a:srgbClr val="586C73"/>
+                </a:solidFill>
+                <a:latin typeface="Arial"/>
+                <a:ea typeface="Arial"/>
+                <a:cs typeface="Arial"/>
+              </a:rPr>
+              <a:t>Без реального управления.</a:t>
+            </a:r>
+          </a:p>
+        </p:txBody>
+      </p:sp>
+    </p:spTree>
+    <p:extLst>
+      <p:ext uri="{BB962C8B-B14F-4D97-AF65-F5344CB8AC3E}">
+        <p14:creationId xmlns:p14="http://schemas.microsoft.com/office/powerpoint/2010/main" val="749060703"/>
+      </p:ext>
+    </p:extLst>
+  </p:cSld>
+</p:sld>
+</file>
+
+<file path=ppt/slides/slide14.xml><?xml version="1.0" encoding="utf-8"?>
 <p:sld xmlns:p="http://schemas.openxmlformats.org/presentationml/2006/main">
   <p:cSld>
     <p:bg>
@@ -4025,7 +5483,7 @@
           <p:cNvPr id="10" name="">
             <a:extLst xmlns:a="http://schemas.openxmlformats.org/drawingml/2006/main">
               <a:ext uri="{FF2B5EF4-FFF2-40B4-BE49-F238E27FC236}">
-                <a16:creationId xmlns:a16="http://schemas.microsoft.com/office/drawing/2014/main" id="{8062EC41-EA48-40FC-9815-CDE04F6490C6}"/>
+                <a16:creationId xmlns:a16="http://schemas.microsoft.com/office/drawing/2014/main" id="{1D8DD1B4-958E-43EA-831B-BF88C6B6A348}"/>
               </a:ext>
             </a:extLst>
           </p:cNvPr>
@@ -4082,7 +5540,7 @@
           <p:cNvPr id="2" name="">
             <a:extLst xmlns:a="http://schemas.openxmlformats.org/drawingml/2006/main">
               <a:ext uri="{FF2B5EF4-FFF2-40B4-BE49-F238E27FC236}">
-                <a16:creationId xmlns:a16="http://schemas.microsoft.com/office/drawing/2014/main" id="{1F03B1AF-C946-4DFF-BF89-237036A310CA}"/>
+                <a16:creationId xmlns:a16="http://schemas.microsoft.com/office/drawing/2014/main" id="{0126CECD-74AA-4583-A3B3-16C20A3DECFF}"/>
               </a:ext>
             </a:extLst>
           </p:cNvPr>
@@ -4139,7 +5597,7 @@
           <p:cNvPr id="3" name="">
             <a:extLst xmlns:a="http://schemas.openxmlformats.org/drawingml/2006/main">
               <a:ext uri="{FF2B5EF4-FFF2-40B4-BE49-F238E27FC236}">
-                <a16:creationId xmlns:a16="http://schemas.microsoft.com/office/drawing/2014/main" id="{0940944D-4B35-4D51-9E3B-4B19F119BBA2}"/>
+                <a16:creationId xmlns:a16="http://schemas.microsoft.com/office/drawing/2014/main" id="{9EDF52DC-FF1C-4B94-B8AB-0913C302C9EB}"/>
               </a:ext>
             </a:extLst>
           </p:cNvPr>
@@ -4196,7 +5654,7 @@
           <p:cNvPr id="4" name="">
             <a:extLst xmlns:a="http://schemas.openxmlformats.org/drawingml/2006/main">
               <a:ext uri="{FF2B5EF4-FFF2-40B4-BE49-F238E27FC236}">
-                <a16:creationId xmlns:a16="http://schemas.microsoft.com/office/drawing/2014/main" id="{804EE333-BC95-41F4-AC42-9EF6395CC67C}"/>
+                <a16:creationId xmlns:a16="http://schemas.microsoft.com/office/drawing/2014/main" id="{9CCC4DA0-9537-48BA-A8E0-208DE51FAE44}"/>
               </a:ext>
             </a:extLst>
           </p:cNvPr>
@@ -4243,7 +5701,7 @@
                 <a:ea typeface="Arial"/>
                 <a:cs typeface="Arial"/>
               </a:rPr>
-              <a:t>12</a:t>
+              <a:t>14</a:t>
             </a:r>
           </a:p>
         </p:txBody>
@@ -4253,7 +5711,7 @@
           <p:cNvPr id="5" name="">
             <a:extLst xmlns:a="http://schemas.openxmlformats.org/drawingml/2006/main">
               <a:ext uri="{FF2B5EF4-FFF2-40B4-BE49-F238E27FC236}">
-                <a16:creationId xmlns:a16="http://schemas.microsoft.com/office/drawing/2014/main" id="{9ECF55A4-E0B2-4729-96A7-FDE7BC9C0862}"/>
+                <a16:creationId xmlns:a16="http://schemas.microsoft.com/office/drawing/2014/main" id="{6259EA80-8249-46F1-8531-BB917AC79747}"/>
               </a:ext>
             </a:extLst>
           </p:cNvPr>
@@ -4310,7 +5768,7 @@
           <p:cNvPr id="6" name="">
             <a:extLst xmlns:a="http://schemas.openxmlformats.org/drawingml/2006/main">
               <a:ext uri="{FF2B5EF4-FFF2-40B4-BE49-F238E27FC236}">
-                <a16:creationId xmlns:a16="http://schemas.microsoft.com/office/drawing/2014/main" id="{1E3478FE-B26C-46CE-A349-F63E54E8D6FB}"/>
+                <a16:creationId xmlns:a16="http://schemas.microsoft.com/office/drawing/2014/main" id="{7F20724A-6972-400E-98E6-199DB483C696}"/>
               </a:ext>
             </a:extLst>
           </p:cNvPr>
@@ -4367,7 +5825,7 @@
           <p:cNvPr id="7" name="">
             <a:extLst xmlns:a="http://schemas.openxmlformats.org/drawingml/2006/main">
               <a:ext uri="{FF2B5EF4-FFF2-40B4-BE49-F238E27FC236}">
-                <a16:creationId xmlns:a16="http://schemas.microsoft.com/office/drawing/2014/main" id="{A9634ED3-8EBC-4F47-963C-9AA224F728A9}"/>
+                <a16:creationId xmlns:a16="http://schemas.microsoft.com/office/drawing/2014/main" id="{94D9D5C5-8431-4219-91A1-46F75CE50D7D}"/>
               </a:ext>
             </a:extLst>
           </p:cNvPr>
@@ -4447,7 +5905,7 @@
           <p:cNvPr id="8" name="">
             <a:extLst xmlns:a="http://schemas.openxmlformats.org/drawingml/2006/main">
               <a:ext uri="{FF2B5EF4-FFF2-40B4-BE49-F238E27FC236}">
-                <a16:creationId xmlns:a16="http://schemas.microsoft.com/office/drawing/2014/main" id="{034B1197-BDDE-48C6-9D31-8BF0778ECD78}"/>
+                <a16:creationId xmlns:a16="http://schemas.microsoft.com/office/drawing/2014/main" id="{6658BDA6-614D-4B66-B851-3BB2209DDA00}"/>
               </a:ext>
             </a:extLst>
           </p:cNvPr>
@@ -4504,7 +5962,7 @@
           <p:cNvPr id="9" name="">
             <a:extLst xmlns:a="http://schemas.openxmlformats.org/drawingml/2006/main">
               <a:ext uri="{FF2B5EF4-FFF2-40B4-BE49-F238E27FC236}">
-                <a16:creationId xmlns:a16="http://schemas.microsoft.com/office/drawing/2014/main" id="{26F6FF7B-E2C9-4F36-B15D-14099EE3BD55}"/>
+                <a16:creationId xmlns:a16="http://schemas.microsoft.com/office/drawing/2014/main" id="{8032D9C1-A091-4A66-A020-ECB4143DE513}"/>
               </a:ext>
             </a:extLst>
           </p:cNvPr>
@@ -4582,7 +6040,7 @@
     </p:spTree>
     <p:extLst>
       <p:ext uri="{BB962C8B-B14F-4D97-AF65-F5344CB8AC3E}">
-        <p14:creationId xmlns:p14="http://schemas.microsoft.com/office/powerpoint/2010/main" val="2057422408"/>
+        <p14:creationId xmlns:p14="http://schemas.microsoft.com/office/powerpoint/2010/main" val="1838501390"/>
       </p:ext>
     </p:extLst>
   </p:cSld>
@@ -4613,7 +6071,7 @@
           <p:cNvPr id="12" name="">
             <a:extLst xmlns:a="http://schemas.openxmlformats.org/drawingml/2006/main">
               <a:ext uri="{FF2B5EF4-FFF2-40B4-BE49-F238E27FC236}">
-                <a16:creationId xmlns:a16="http://schemas.microsoft.com/office/drawing/2014/main" id="{BAAC2206-0356-4B6C-82C3-25A9596926F8}"/>
+                <a16:creationId xmlns:a16="http://schemas.microsoft.com/office/drawing/2014/main" id="{6F9A19E1-A730-4EE4-9A93-CF763DCFFDF1}"/>
               </a:ext>
             </a:extLst>
           </p:cNvPr>
@@ -4670,7 +6128,7 @@
           <p:cNvPr id="2" name="">
             <a:extLst xmlns:a="http://schemas.openxmlformats.org/drawingml/2006/main">
               <a:ext uri="{FF2B5EF4-FFF2-40B4-BE49-F238E27FC236}">
-                <a16:creationId xmlns:a16="http://schemas.microsoft.com/office/drawing/2014/main" id="{21FF4403-16CE-40CF-983A-4736F4934C48}"/>
+                <a16:creationId xmlns:a16="http://schemas.microsoft.com/office/drawing/2014/main" id="{63EE76A7-E412-4E2A-B4AC-93050A2F9BC6}"/>
               </a:ext>
             </a:extLst>
           </p:cNvPr>
@@ -4727,7 +6185,7 @@
           <p:cNvPr id="3" name="">
             <a:extLst xmlns:a="http://schemas.openxmlformats.org/drawingml/2006/main">
               <a:ext uri="{FF2B5EF4-FFF2-40B4-BE49-F238E27FC236}">
-                <a16:creationId xmlns:a16="http://schemas.microsoft.com/office/drawing/2014/main" id="{50099D6C-98E7-4ADC-BE6B-5EF661C47131}"/>
+                <a16:creationId xmlns:a16="http://schemas.microsoft.com/office/drawing/2014/main" id="{40BB014A-ED8B-4D7B-8EC1-1155AD2EBF00}"/>
               </a:ext>
             </a:extLst>
           </p:cNvPr>
@@ -4784,7 +6242,7 @@
           <p:cNvPr id="4" name="">
             <a:extLst xmlns:a="http://schemas.openxmlformats.org/drawingml/2006/main">
               <a:ext uri="{FF2B5EF4-FFF2-40B4-BE49-F238E27FC236}">
-                <a16:creationId xmlns:a16="http://schemas.microsoft.com/office/drawing/2014/main" id="{075701EB-34EE-41E9-B2CA-42729E9F0BE7}"/>
+                <a16:creationId xmlns:a16="http://schemas.microsoft.com/office/drawing/2014/main" id="{17700E49-83F3-4B07-95D8-12DA6E3C4642}"/>
               </a:ext>
             </a:extLst>
           </p:cNvPr>
@@ -4841,7 +6299,7 @@
           <p:cNvPr id="5" name="">
             <a:extLst xmlns:a="http://schemas.openxmlformats.org/drawingml/2006/main">
               <a:ext uri="{FF2B5EF4-FFF2-40B4-BE49-F238E27FC236}">
-                <a16:creationId xmlns:a16="http://schemas.microsoft.com/office/drawing/2014/main" id="{3BE0A39B-BEFD-430F-8B64-E062CCACE1E9}"/>
+                <a16:creationId xmlns:a16="http://schemas.microsoft.com/office/drawing/2014/main" id="{C2659458-715B-4C97-915D-C683EA697030}"/>
               </a:ext>
             </a:extLst>
           </p:cNvPr>
@@ -4898,7 +6356,7 @@
           <p:cNvPr id="6" name="">
             <a:extLst xmlns:a="http://schemas.openxmlformats.org/drawingml/2006/main">
               <a:ext uri="{FF2B5EF4-FFF2-40B4-BE49-F238E27FC236}">
-                <a16:creationId xmlns:a16="http://schemas.microsoft.com/office/drawing/2014/main" id="{5441B198-FDC1-4FF0-A108-A1B6EF409AE1}"/>
+                <a16:creationId xmlns:a16="http://schemas.microsoft.com/office/drawing/2014/main" id="{7B11E603-0644-464D-A8AA-FC033289E7EF}"/>
               </a:ext>
             </a:extLst>
           </p:cNvPr>
@@ -4955,7 +6413,7 @@
           <p:cNvPr id="7" name="">
             <a:extLst xmlns:a="http://schemas.openxmlformats.org/drawingml/2006/main">
               <a:ext uri="{FF2B5EF4-FFF2-40B4-BE49-F238E27FC236}">
-                <a16:creationId xmlns:a16="http://schemas.microsoft.com/office/drawing/2014/main" id="{626F3489-C36A-42B0-85C6-02ECC64E0DE7}"/>
+                <a16:creationId xmlns:a16="http://schemas.microsoft.com/office/drawing/2014/main" id="{1FE856AD-387B-404B-8004-EE1BC8B2BE9A}"/>
               </a:ext>
             </a:extLst>
           </p:cNvPr>
@@ -5012,7 +6470,7 @@
           <p:cNvPr id="8" name="">
             <a:extLst xmlns:a="http://schemas.openxmlformats.org/drawingml/2006/main">
               <a:ext uri="{FF2B5EF4-FFF2-40B4-BE49-F238E27FC236}">
-                <a16:creationId xmlns:a16="http://schemas.microsoft.com/office/drawing/2014/main" id="{C34C214B-D1FE-452B-B74D-D0430C98B54B}"/>
+                <a16:creationId xmlns:a16="http://schemas.microsoft.com/office/drawing/2014/main" id="{07D7991B-CE7C-4ED4-BE30-06D3CF7D1B32}"/>
               </a:ext>
             </a:extLst>
           </p:cNvPr>
@@ -5069,7 +6527,7 @@
           <p:cNvPr id="9" name="">
             <a:extLst xmlns:a="http://schemas.openxmlformats.org/drawingml/2006/main">
               <a:ext uri="{FF2B5EF4-FFF2-40B4-BE49-F238E27FC236}">
-                <a16:creationId xmlns:a16="http://schemas.microsoft.com/office/drawing/2014/main" id="{9B754531-032F-4E6E-8DCE-68A3487CE268}"/>
+                <a16:creationId xmlns:a16="http://schemas.microsoft.com/office/drawing/2014/main" id="{4BD79ADB-DE23-47B0-97C1-ADC85A6273EC}"/>
               </a:ext>
             </a:extLst>
           </p:cNvPr>
@@ -5126,7 +6584,7 @@
           <p:cNvPr id="10" name="">
             <a:extLst xmlns:a="http://schemas.openxmlformats.org/drawingml/2006/main">
               <a:ext uri="{FF2B5EF4-FFF2-40B4-BE49-F238E27FC236}">
-                <a16:creationId xmlns:a16="http://schemas.microsoft.com/office/drawing/2014/main" id="{91A3C454-7542-4B68-9972-D8159D3D56B2}"/>
+                <a16:creationId xmlns:a16="http://schemas.microsoft.com/office/drawing/2014/main" id="{D2BC1D10-7906-4C11-8DCB-C20E8B23C80F}"/>
               </a:ext>
             </a:extLst>
           </p:cNvPr>
@@ -5183,7 +6641,7 @@
           <p:cNvPr id="11" name="">
             <a:extLst xmlns:a="http://schemas.openxmlformats.org/drawingml/2006/main">
               <a:ext uri="{FF2B5EF4-FFF2-40B4-BE49-F238E27FC236}">
-                <a16:creationId xmlns:a16="http://schemas.microsoft.com/office/drawing/2014/main" id="{D2E78D02-8D63-4F27-9070-6D80D8BA1D71}"/>
+                <a16:creationId xmlns:a16="http://schemas.microsoft.com/office/drawing/2014/main" id="{06397EDF-087B-4369-B36B-88F57D349694}"/>
               </a:ext>
             </a:extLst>
           </p:cNvPr>
@@ -5238,7 +6696,7 @@
     </p:spTree>
     <p:extLst>
       <p:ext uri="{BB962C8B-B14F-4D97-AF65-F5344CB8AC3E}">
-        <p14:creationId xmlns:p14="http://schemas.microsoft.com/office/powerpoint/2010/main" val="991133614"/>
+        <p14:creationId xmlns:p14="http://schemas.microsoft.com/office/powerpoint/2010/main" val="63260658"/>
       </p:ext>
     </p:extLst>
   </p:cSld>
@@ -5269,7 +6727,7 @@
           <p:cNvPr id="13" name="">
             <a:extLst xmlns:a="http://schemas.openxmlformats.org/drawingml/2006/main">
               <a:ext uri="{FF2B5EF4-FFF2-40B4-BE49-F238E27FC236}">
-                <a16:creationId xmlns:a16="http://schemas.microsoft.com/office/drawing/2014/main" id="{75DC0E93-703A-488B-A49E-A69BAD857AFB}"/>
+                <a16:creationId xmlns:a16="http://schemas.microsoft.com/office/drawing/2014/main" id="{C8A814AD-8936-4ADB-B7AF-E418E45ED3A7}"/>
               </a:ext>
             </a:extLst>
           </p:cNvPr>
@@ -5326,7 +6784,7 @@
           <p:cNvPr id="2" name="">
             <a:extLst xmlns:a="http://schemas.openxmlformats.org/drawingml/2006/main">
               <a:ext uri="{FF2B5EF4-FFF2-40B4-BE49-F238E27FC236}">
-                <a16:creationId xmlns:a16="http://schemas.microsoft.com/office/drawing/2014/main" id="{77E31753-5B09-4D09-AF3D-74EA341CDEED}"/>
+                <a16:creationId xmlns:a16="http://schemas.microsoft.com/office/drawing/2014/main" id="{20A67545-D7DF-44C5-A3A4-D97410989B7F}"/>
               </a:ext>
             </a:extLst>
           </p:cNvPr>
@@ -5383,7 +6841,7 @@
           <p:cNvPr id="3" name="">
             <a:extLst xmlns:a="http://schemas.openxmlformats.org/drawingml/2006/main">
               <a:ext uri="{FF2B5EF4-FFF2-40B4-BE49-F238E27FC236}">
-                <a16:creationId xmlns:a16="http://schemas.microsoft.com/office/drawing/2014/main" id="{6B9D63DA-80BF-45FF-9559-68DC7C60C7A6}"/>
+                <a16:creationId xmlns:a16="http://schemas.microsoft.com/office/drawing/2014/main" id="{6AFA42E6-3820-4AB8-8DA2-7CBF6FB4D3E1}"/>
               </a:ext>
             </a:extLst>
           </p:cNvPr>
@@ -5440,7 +6898,7 @@
           <p:cNvPr id="4" name="">
             <a:extLst xmlns:a="http://schemas.openxmlformats.org/drawingml/2006/main">
               <a:ext uri="{FF2B5EF4-FFF2-40B4-BE49-F238E27FC236}">
-                <a16:creationId xmlns:a16="http://schemas.microsoft.com/office/drawing/2014/main" id="{74D0D74E-A442-4EAE-B49A-1A568DB04FA9}"/>
+                <a16:creationId xmlns:a16="http://schemas.microsoft.com/office/drawing/2014/main" id="{6B047483-37C6-4F7B-AA64-38FF789B42B6}"/>
               </a:ext>
             </a:extLst>
           </p:cNvPr>
@@ -5497,7 +6955,7 @@
           <p:cNvPr id="5" name="">
             <a:extLst xmlns:a="http://schemas.openxmlformats.org/drawingml/2006/main">
               <a:ext uri="{FF2B5EF4-FFF2-40B4-BE49-F238E27FC236}">
-                <a16:creationId xmlns:a16="http://schemas.microsoft.com/office/drawing/2014/main" id="{A6533972-9838-4E60-BEA6-BDED47577B9B}"/>
+                <a16:creationId xmlns:a16="http://schemas.microsoft.com/office/drawing/2014/main" id="{87EC4545-3F91-4114-8A2D-2525D3927C93}"/>
               </a:ext>
             </a:extLst>
           </p:cNvPr>
@@ -5554,7 +7012,7 @@
           <p:cNvPr id="6" name="">
             <a:extLst xmlns:a="http://schemas.openxmlformats.org/drawingml/2006/main">
               <a:ext uri="{FF2B5EF4-FFF2-40B4-BE49-F238E27FC236}">
-                <a16:creationId xmlns:a16="http://schemas.microsoft.com/office/drawing/2014/main" id="{03494F88-F678-4D2A-B512-95279587F92A}"/>
+                <a16:creationId xmlns:a16="http://schemas.microsoft.com/office/drawing/2014/main" id="{8088100B-C76F-477E-8F29-95BC9D11648B}"/>
               </a:ext>
             </a:extLst>
           </p:cNvPr>
@@ -5611,7 +7069,7 @@
           <p:cNvPr id="7" name="">
             <a:extLst xmlns:a="http://schemas.openxmlformats.org/drawingml/2006/main">
               <a:ext uri="{FF2B5EF4-FFF2-40B4-BE49-F238E27FC236}">
-                <a16:creationId xmlns:a16="http://schemas.microsoft.com/office/drawing/2014/main" id="{9916CEB2-F806-400F-81F5-5E1CD3DE6E71}"/>
+                <a16:creationId xmlns:a16="http://schemas.microsoft.com/office/drawing/2014/main" id="{CD37CF5C-5BCC-4E09-A4C4-7BF2CEF21118}"/>
               </a:ext>
             </a:extLst>
           </p:cNvPr>
@@ -5668,7 +7126,7 @@
           <p:cNvPr id="8" name="">
             <a:extLst xmlns:a="http://schemas.openxmlformats.org/drawingml/2006/main">
               <a:ext uri="{FF2B5EF4-FFF2-40B4-BE49-F238E27FC236}">
-                <a16:creationId xmlns:a16="http://schemas.microsoft.com/office/drawing/2014/main" id="{7909478D-08AB-4298-A3CE-27348220F793}"/>
+                <a16:creationId xmlns:a16="http://schemas.microsoft.com/office/drawing/2014/main" id="{43DCD3A5-AD3A-443B-9136-1478AA42C46D}"/>
               </a:ext>
             </a:extLst>
           </p:cNvPr>
@@ -5748,7 +7206,7 @@
           <p:cNvPr id="9" name="">
             <a:extLst xmlns:a="http://schemas.openxmlformats.org/drawingml/2006/main">
               <a:ext uri="{FF2B5EF4-FFF2-40B4-BE49-F238E27FC236}">
-                <a16:creationId xmlns:a16="http://schemas.microsoft.com/office/drawing/2014/main" id="{D624C2B7-C9CB-4E33-A78E-3D20AE7AA88C}"/>
+                <a16:creationId xmlns:a16="http://schemas.microsoft.com/office/drawing/2014/main" id="{37C340B4-1BCD-4F10-A727-D7E22C05ED4D}"/>
               </a:ext>
             </a:extLst>
           </p:cNvPr>
@@ -5828,7 +7286,7 @@
           <p:cNvPr id="10" name="">
             <a:extLst xmlns:a="http://schemas.openxmlformats.org/drawingml/2006/main">
               <a:ext uri="{FF2B5EF4-FFF2-40B4-BE49-F238E27FC236}">
-                <a16:creationId xmlns:a16="http://schemas.microsoft.com/office/drawing/2014/main" id="{3F9DAB77-E09A-4657-ADF6-DD2370B02AEE}"/>
+                <a16:creationId xmlns:a16="http://schemas.microsoft.com/office/drawing/2014/main" id="{FCD105C9-1F52-4BE1-8F7A-74F6B609DB99}"/>
               </a:ext>
             </a:extLst>
           </p:cNvPr>
@@ -5908,7 +7366,7 @@
           <p:cNvPr id="11" name="">
             <a:extLst xmlns:a="http://schemas.openxmlformats.org/drawingml/2006/main">
               <a:ext uri="{FF2B5EF4-FFF2-40B4-BE49-F238E27FC236}">
-                <a16:creationId xmlns:a16="http://schemas.microsoft.com/office/drawing/2014/main" id="{718D595A-69F6-422A-B916-0B433E57BD71}"/>
+                <a16:creationId xmlns:a16="http://schemas.microsoft.com/office/drawing/2014/main" id="{1B740CAA-703D-4C26-8B3A-09E92237918C}"/>
               </a:ext>
             </a:extLst>
           </p:cNvPr>
@@ -5965,7 +7423,7 @@
           <p:cNvPr id="12" name="">
             <a:extLst xmlns:a="http://schemas.openxmlformats.org/drawingml/2006/main">
               <a:ext uri="{FF2B5EF4-FFF2-40B4-BE49-F238E27FC236}">
-                <a16:creationId xmlns:a16="http://schemas.microsoft.com/office/drawing/2014/main" id="{3F25862E-FC2F-4881-A4D4-6A3BE817A8CD}"/>
+                <a16:creationId xmlns:a16="http://schemas.microsoft.com/office/drawing/2014/main" id="{9A1BF063-7CBE-4717-BF68-80804EEB3510}"/>
               </a:ext>
             </a:extLst>
           </p:cNvPr>
@@ -6020,7 +7478,7 @@
     </p:spTree>
     <p:extLst>
       <p:ext uri="{BB962C8B-B14F-4D97-AF65-F5344CB8AC3E}">
-        <p14:creationId xmlns:p14="http://schemas.microsoft.com/office/powerpoint/2010/main" val="475365939"/>
+        <p14:creationId xmlns:p14="http://schemas.microsoft.com/office/powerpoint/2010/main" val="993761690"/>
       </p:ext>
     </p:extLst>
   </p:cSld>
@@ -6051,7 +7509,7 @@
           <p:cNvPr id="7" name="">
             <a:extLst xmlns:a="http://schemas.openxmlformats.org/drawingml/2006/main">
               <a:ext uri="{FF2B5EF4-FFF2-40B4-BE49-F238E27FC236}">
-                <a16:creationId xmlns:a16="http://schemas.microsoft.com/office/drawing/2014/main" id="{B6DEC626-6AA5-467F-BCA1-A873FFB15A06}"/>
+                <a16:creationId xmlns:a16="http://schemas.microsoft.com/office/drawing/2014/main" id="{E74A78C0-512F-4E13-AA7C-8D9F80170698}"/>
               </a:ext>
             </a:extLst>
           </p:cNvPr>
@@ -6108,7 +7566,7 @@
           <p:cNvPr id="2" name="">
             <a:extLst xmlns:a="http://schemas.openxmlformats.org/drawingml/2006/main">
               <a:ext uri="{FF2B5EF4-FFF2-40B4-BE49-F238E27FC236}">
-                <a16:creationId xmlns:a16="http://schemas.microsoft.com/office/drawing/2014/main" id="{71C707BC-E874-4D9B-BA24-58C9DBCB5B76}"/>
+                <a16:creationId xmlns:a16="http://schemas.microsoft.com/office/drawing/2014/main" id="{1A17E25C-5424-428D-A313-E659E1BC60E6}"/>
               </a:ext>
             </a:extLst>
           </p:cNvPr>
@@ -6165,7 +7623,7 @@
           <p:cNvPr id="3" name="">
             <a:extLst xmlns:a="http://schemas.openxmlformats.org/drawingml/2006/main">
               <a:ext uri="{FF2B5EF4-FFF2-40B4-BE49-F238E27FC236}">
-                <a16:creationId xmlns:a16="http://schemas.microsoft.com/office/drawing/2014/main" id="{CB608C5E-47CC-4517-89DA-65575244A593}"/>
+                <a16:creationId xmlns:a16="http://schemas.microsoft.com/office/drawing/2014/main" id="{FA6E4DCA-7D2B-47D7-BCD2-2CD6F96F68EB}"/>
               </a:ext>
             </a:extLst>
           </p:cNvPr>
@@ -6222,7 +7680,7 @@
           <p:cNvPr id="4" name="">
             <a:extLst xmlns:a="http://schemas.openxmlformats.org/drawingml/2006/main">
               <a:ext uri="{FF2B5EF4-FFF2-40B4-BE49-F238E27FC236}">
-                <a16:creationId xmlns:a16="http://schemas.microsoft.com/office/drawing/2014/main" id="{EA2E71BE-53DE-453F-92E3-16DC01CE9A2B}"/>
+                <a16:creationId xmlns:a16="http://schemas.microsoft.com/office/drawing/2014/main" id="{CC030F67-BBD2-4CBB-95B8-76E5996BAF24}"/>
               </a:ext>
             </a:extLst>
           </p:cNvPr>
@@ -6551,7 +8009,7 @@
           <p:cNvPr id="6" name="">
             <a:extLst xmlns:a="http://schemas.openxmlformats.org/drawingml/2006/main">
               <a:ext uri="{FF2B5EF4-FFF2-40B4-BE49-F238E27FC236}">
-                <a16:creationId xmlns:a16="http://schemas.microsoft.com/office/drawing/2014/main" id="{5D1C3D3A-DFAB-4967-AF30-E3EB1811E2A0}"/>
+                <a16:creationId xmlns:a16="http://schemas.microsoft.com/office/drawing/2014/main" id="{F63471B4-9737-4258-BFFD-23406B763DA7}"/>
               </a:ext>
             </a:extLst>
           </p:cNvPr>
@@ -6606,7 +8064,7 @@
     </p:spTree>
     <p:extLst>
       <p:ext uri="{BB962C8B-B14F-4D97-AF65-F5344CB8AC3E}">
-        <p14:creationId xmlns:p14="http://schemas.microsoft.com/office/powerpoint/2010/main" val="1484176637"/>
+        <p14:creationId xmlns:p14="http://schemas.microsoft.com/office/powerpoint/2010/main" val="1040157193"/>
       </p:ext>
     </p:extLst>
   </p:cSld>
@@ -6637,7 +8095,7 @@
           <p:cNvPr id="10" name="">
             <a:extLst xmlns:a="http://schemas.openxmlformats.org/drawingml/2006/main">
               <a:ext uri="{FF2B5EF4-FFF2-40B4-BE49-F238E27FC236}">
-                <a16:creationId xmlns:a16="http://schemas.microsoft.com/office/drawing/2014/main" id="{3FBC7F9E-0973-401B-A0F8-FF52B92F94EA}"/>
+                <a16:creationId xmlns:a16="http://schemas.microsoft.com/office/drawing/2014/main" id="{DCEBF287-D0D2-4C18-8179-019EE2FF149A}"/>
               </a:ext>
             </a:extLst>
           </p:cNvPr>
@@ -6694,7 +8152,7 @@
           <p:cNvPr id="2" name="">
             <a:extLst xmlns:a="http://schemas.openxmlformats.org/drawingml/2006/main">
               <a:ext uri="{FF2B5EF4-FFF2-40B4-BE49-F238E27FC236}">
-                <a16:creationId xmlns:a16="http://schemas.microsoft.com/office/drawing/2014/main" id="{8E0CAB8F-7125-471C-B64C-2BF6E18FF028}"/>
+                <a16:creationId xmlns:a16="http://schemas.microsoft.com/office/drawing/2014/main" id="{4CA3248C-849A-48D5-865E-F7AFBEAFBCAD}"/>
               </a:ext>
             </a:extLst>
           </p:cNvPr>
@@ -6751,7 +8209,7 @@
           <p:cNvPr id="3" name="">
             <a:extLst xmlns:a="http://schemas.openxmlformats.org/drawingml/2006/main">
               <a:ext uri="{FF2B5EF4-FFF2-40B4-BE49-F238E27FC236}">
-                <a16:creationId xmlns:a16="http://schemas.microsoft.com/office/drawing/2014/main" id="{FEAB568B-5697-4266-A836-972D019E5C69}"/>
+                <a16:creationId xmlns:a16="http://schemas.microsoft.com/office/drawing/2014/main" id="{32D0DA61-8EDC-406D-ABC2-01DED7A8D067}"/>
               </a:ext>
             </a:extLst>
           </p:cNvPr>
@@ -6808,7 +8266,7 @@
           <p:cNvPr id="4" name="">
             <a:extLst xmlns:a="http://schemas.openxmlformats.org/drawingml/2006/main">
               <a:ext uri="{FF2B5EF4-FFF2-40B4-BE49-F238E27FC236}">
-                <a16:creationId xmlns:a16="http://schemas.microsoft.com/office/drawing/2014/main" id="{466DAC70-724A-4344-81B8-AC7668567481}"/>
+                <a16:creationId xmlns:a16="http://schemas.microsoft.com/office/drawing/2014/main" id="{A6F22565-608F-4B2D-96B2-BDEC96FE7BF7}"/>
               </a:ext>
             </a:extLst>
           </p:cNvPr>
@@ -6869,13 +8327,13 @@
           <p:nvPr/>
         </p:nvPicPr>
         <p:blipFill>
-          <a:blip xmlns:r="http://schemas.openxmlformats.org/officeDocument/2006/relationships" xmlns:a="http://schemas.openxmlformats.org/drawingml/2006/main" r:embed="Reebbf293291c4237"/>
+          <a:blip xmlns:r="http://schemas.openxmlformats.org/officeDocument/2006/relationships" xmlns:a="http://schemas.openxmlformats.org/drawingml/2006/main" r:embed="R46515a79bac24d74"/>
           <a:stretch xmlns:a="http://schemas.openxmlformats.org/drawingml/2006/main"/>
         </p:blipFill>
         <p:spPr>
           <a:xfrm xmlns:a="http://schemas.openxmlformats.org/drawingml/2006/main">
-            <a:off x="613516" y="1885950"/>
-            <a:ext cx="6326293" cy="4448175"/>
+            <a:off x="609600" y="2178459"/>
+            <a:ext cx="6334125" cy="3863156"/>
           </a:xfrm>
           <a:prstGeom xmlns:a="http://schemas.openxmlformats.org/drawingml/2006/main" prst="rect">
             <a:avLst/>
@@ -6887,7 +8345,7 @@
           <p:cNvPr id="6" name="">
             <a:extLst xmlns:a="http://schemas.openxmlformats.org/drawingml/2006/main">
               <a:ext uri="{FF2B5EF4-FFF2-40B4-BE49-F238E27FC236}">
-                <a16:creationId xmlns:a16="http://schemas.microsoft.com/office/drawing/2014/main" id="{5671B655-B8C2-4DF1-BB88-15859799C1F0}"/>
+                <a16:creationId xmlns:a16="http://schemas.microsoft.com/office/drawing/2014/main" id="{1874DA62-ED2A-4AC0-9C7F-FB8356F938F8}"/>
               </a:ext>
             </a:extLst>
           </p:cNvPr>
@@ -6944,7 +8402,7 @@
           <p:cNvPr id="7" name="">
             <a:extLst xmlns:a="http://schemas.openxmlformats.org/drawingml/2006/main">
               <a:ext uri="{FF2B5EF4-FFF2-40B4-BE49-F238E27FC236}">
-                <a16:creationId xmlns:a16="http://schemas.microsoft.com/office/drawing/2014/main" id="{A9B02BAE-BD9D-43CA-8E59-3BAA47AA112A}"/>
+                <a16:creationId xmlns:a16="http://schemas.microsoft.com/office/drawing/2014/main" id="{3696A5BB-4A6A-484B-922B-69633022B9FD}"/>
               </a:ext>
             </a:extLst>
           </p:cNvPr>
@@ -7024,7 +8482,7 @@
           <p:cNvPr id="8" name="">
             <a:extLst xmlns:a="http://schemas.openxmlformats.org/drawingml/2006/main">
               <a:ext uri="{FF2B5EF4-FFF2-40B4-BE49-F238E27FC236}">
-                <a16:creationId xmlns:a16="http://schemas.microsoft.com/office/drawing/2014/main" id="{416ECBA6-3530-499F-9D2A-F42D329A0CB3}"/>
+                <a16:creationId xmlns:a16="http://schemas.microsoft.com/office/drawing/2014/main" id="{3E759611-2291-4B41-9C24-8F6B2E1F75E2}"/>
               </a:ext>
             </a:extLst>
           </p:cNvPr>
@@ -7104,7 +8562,7 @@
           <p:cNvPr id="9" name="">
             <a:extLst xmlns:a="http://schemas.openxmlformats.org/drawingml/2006/main">
               <a:ext uri="{FF2B5EF4-FFF2-40B4-BE49-F238E27FC236}">
-                <a16:creationId xmlns:a16="http://schemas.microsoft.com/office/drawing/2014/main" id="{D49D830E-E150-4706-8195-6EA6AD3BEFB4}"/>
+                <a16:creationId xmlns:a16="http://schemas.microsoft.com/office/drawing/2014/main" id="{E3C18C02-5C69-4D6D-83B0-00015E44A775}"/>
               </a:ext>
             </a:extLst>
           </p:cNvPr>
@@ -7159,7 +8617,7 @@
     </p:spTree>
     <p:extLst>
       <p:ext uri="{BB962C8B-B14F-4D97-AF65-F5344CB8AC3E}">
-        <p14:creationId xmlns:p14="http://schemas.microsoft.com/office/powerpoint/2010/main" val="2076370814"/>
+        <p14:creationId xmlns:p14="http://schemas.microsoft.com/office/powerpoint/2010/main" val="420427071"/>
       </p:ext>
     </p:extLst>
   </p:cSld>
@@ -7190,7 +8648,7 @@
           <p:cNvPr id="6" name="">
             <a:extLst xmlns:a="http://schemas.openxmlformats.org/drawingml/2006/main">
               <a:ext uri="{FF2B5EF4-FFF2-40B4-BE49-F238E27FC236}">
-                <a16:creationId xmlns:a16="http://schemas.microsoft.com/office/drawing/2014/main" id="{8D2D6CDD-6A07-4D67-9A05-58F4FA1B5702}"/>
+                <a16:creationId xmlns:a16="http://schemas.microsoft.com/office/drawing/2014/main" id="{35BE2EA7-8B10-45C4-AD0E-397DFBA2A40D}"/>
               </a:ext>
             </a:extLst>
           </p:cNvPr>
@@ -7247,7 +8705,7 @@
           <p:cNvPr id="2" name="">
             <a:extLst xmlns:a="http://schemas.openxmlformats.org/drawingml/2006/main">
               <a:ext uri="{FF2B5EF4-FFF2-40B4-BE49-F238E27FC236}">
-                <a16:creationId xmlns:a16="http://schemas.microsoft.com/office/drawing/2014/main" id="{964A3E55-EA98-438D-8CE7-DFCBD6933133}"/>
+                <a16:creationId xmlns:a16="http://schemas.microsoft.com/office/drawing/2014/main" id="{47ACBFAC-23AD-4B6B-A827-4DB636DD736A}"/>
               </a:ext>
             </a:extLst>
           </p:cNvPr>
@@ -7304,7 +8762,7 @@
           <p:cNvPr id="3" name="">
             <a:extLst xmlns:a="http://schemas.openxmlformats.org/drawingml/2006/main">
               <a:ext uri="{FF2B5EF4-FFF2-40B4-BE49-F238E27FC236}">
-                <a16:creationId xmlns:a16="http://schemas.microsoft.com/office/drawing/2014/main" id="{93C57F63-A997-409C-A23C-35E04C8158C2}"/>
+                <a16:creationId xmlns:a16="http://schemas.microsoft.com/office/drawing/2014/main" id="{7CC0A73C-32DA-4A8B-BDB9-FC3E81DDCDCA}"/>
               </a:ext>
             </a:extLst>
           </p:cNvPr>
@@ -7361,7 +8819,7 @@
           <p:cNvPr id="4" name="">
             <a:extLst xmlns:a="http://schemas.openxmlformats.org/drawingml/2006/main">
               <a:ext uri="{FF2B5EF4-FFF2-40B4-BE49-F238E27FC236}">
-                <a16:creationId xmlns:a16="http://schemas.microsoft.com/office/drawing/2014/main" id="{0A954F0F-ED5A-4CF4-A557-C4D26C1185F8}"/>
+                <a16:creationId xmlns:a16="http://schemas.microsoft.com/office/drawing/2014/main" id="{3BAD7592-4C9D-40DA-8563-531DE79BB940}"/>
               </a:ext>
             </a:extLst>
           </p:cNvPr>
@@ -7957,7 +9415,7 @@
     </p:spTree>
     <p:extLst>
       <p:ext uri="{BB962C8B-B14F-4D97-AF65-F5344CB8AC3E}">
-        <p14:creationId xmlns:p14="http://schemas.microsoft.com/office/powerpoint/2010/main" val="1632726661"/>
+        <p14:creationId xmlns:p14="http://schemas.microsoft.com/office/powerpoint/2010/main" val="1255920859"/>
       </p:ext>
     </p:extLst>
   </p:cSld>
@@ -7988,7 +9446,7 @@
           <p:cNvPr id="8" name="">
             <a:extLst xmlns:a="http://schemas.openxmlformats.org/drawingml/2006/main">
               <a:ext uri="{FF2B5EF4-FFF2-40B4-BE49-F238E27FC236}">
-                <a16:creationId xmlns:a16="http://schemas.microsoft.com/office/drawing/2014/main" id="{AD62C5EA-20FF-4A00-959F-A199A3935817}"/>
+                <a16:creationId xmlns:a16="http://schemas.microsoft.com/office/drawing/2014/main" id="{DCF16568-B2DD-49FD-A342-9699EF309157}"/>
               </a:ext>
             </a:extLst>
           </p:cNvPr>
@@ -8045,7 +9503,7 @@
           <p:cNvPr id="2" name="">
             <a:extLst xmlns:a="http://schemas.openxmlformats.org/drawingml/2006/main">
               <a:ext uri="{FF2B5EF4-FFF2-40B4-BE49-F238E27FC236}">
-                <a16:creationId xmlns:a16="http://schemas.microsoft.com/office/drawing/2014/main" id="{29591204-A2E1-4084-8999-108E4A62D503}"/>
+                <a16:creationId xmlns:a16="http://schemas.microsoft.com/office/drawing/2014/main" id="{44875AFD-D248-4EE7-A2B0-D5399DE81812}"/>
               </a:ext>
             </a:extLst>
           </p:cNvPr>
@@ -8102,7 +9560,7 @@
           <p:cNvPr id="3" name="">
             <a:extLst xmlns:a="http://schemas.openxmlformats.org/drawingml/2006/main">
               <a:ext uri="{FF2B5EF4-FFF2-40B4-BE49-F238E27FC236}">
-                <a16:creationId xmlns:a16="http://schemas.microsoft.com/office/drawing/2014/main" id="{9C6A7476-5E1B-44A8-9106-FDFD328CD0A3}"/>
+                <a16:creationId xmlns:a16="http://schemas.microsoft.com/office/drawing/2014/main" id="{62DAE9F8-B277-45C2-839D-DCA503F1C73F}"/>
               </a:ext>
             </a:extLst>
           </p:cNvPr>
@@ -8159,7 +9617,7 @@
           <p:cNvPr id="4" name="">
             <a:extLst xmlns:a="http://schemas.openxmlformats.org/drawingml/2006/main">
               <a:ext uri="{FF2B5EF4-FFF2-40B4-BE49-F238E27FC236}">
-                <a16:creationId xmlns:a16="http://schemas.microsoft.com/office/drawing/2014/main" id="{0F6E3BCE-6CBB-4775-8759-DCE9C9D23443}"/>
+                <a16:creationId xmlns:a16="http://schemas.microsoft.com/office/drawing/2014/main" id="{07E12A8C-0130-4D34-9438-47A5439A969D}"/>
               </a:ext>
             </a:extLst>
           </p:cNvPr>
@@ -8535,7 +9993,7 @@
           <p:cNvPr id="6" name="">
             <a:extLst xmlns:a="http://schemas.openxmlformats.org/drawingml/2006/main">
               <a:ext uri="{FF2B5EF4-FFF2-40B4-BE49-F238E27FC236}">
-                <a16:creationId xmlns:a16="http://schemas.microsoft.com/office/drawing/2014/main" id="{125087D8-7FCF-43A9-ACE2-0AD1D93ED2D4}"/>
+                <a16:creationId xmlns:a16="http://schemas.microsoft.com/office/drawing/2014/main" id="{7764E336-6BB2-4BA3-8774-EFF0CD218443}"/>
               </a:ext>
             </a:extLst>
           </p:cNvPr>
@@ -8592,7 +10050,7 @@
           <p:cNvPr id="7" name="">
             <a:extLst xmlns:a="http://schemas.openxmlformats.org/drawingml/2006/main">
               <a:ext uri="{FF2B5EF4-FFF2-40B4-BE49-F238E27FC236}">
-                <a16:creationId xmlns:a16="http://schemas.microsoft.com/office/drawing/2014/main" id="{99F99D5D-5804-485F-BDA1-B6FD19CB9A28}"/>
+                <a16:creationId xmlns:a16="http://schemas.microsoft.com/office/drawing/2014/main" id="{56FE2B6E-D142-471C-855A-E78A327CDE51}"/>
               </a:ext>
             </a:extLst>
           </p:cNvPr>
@@ -8647,7 +10105,7 @@
     </p:spTree>
     <p:extLst>
       <p:ext uri="{BB962C8B-B14F-4D97-AF65-F5344CB8AC3E}">
-        <p14:creationId xmlns:p14="http://schemas.microsoft.com/office/powerpoint/2010/main" val="1846672616"/>
+        <p14:creationId xmlns:p14="http://schemas.microsoft.com/office/powerpoint/2010/main" val="1542350863"/>
       </p:ext>
     </p:extLst>
   </p:cSld>
@@ -8678,7 +10136,7 @@
           <p:cNvPr id="8" name="">
             <a:extLst xmlns:a="http://schemas.openxmlformats.org/drawingml/2006/main">
               <a:ext uri="{FF2B5EF4-FFF2-40B4-BE49-F238E27FC236}">
-                <a16:creationId xmlns:a16="http://schemas.microsoft.com/office/drawing/2014/main" id="{F38627D4-69F5-45A0-89CB-C54D694ADFD5}"/>
+                <a16:creationId xmlns:a16="http://schemas.microsoft.com/office/drawing/2014/main" id="{02653B8E-6633-4EC4-8E8F-F2F0737D1CCE}"/>
               </a:ext>
             </a:extLst>
           </p:cNvPr>
@@ -8735,7 +10193,7 @@
           <p:cNvPr id="2" name="">
             <a:extLst xmlns:a="http://schemas.openxmlformats.org/drawingml/2006/main">
               <a:ext uri="{FF2B5EF4-FFF2-40B4-BE49-F238E27FC236}">
-                <a16:creationId xmlns:a16="http://schemas.microsoft.com/office/drawing/2014/main" id="{831F9821-9009-4C7C-ADDB-4056468E5C55}"/>
+                <a16:creationId xmlns:a16="http://schemas.microsoft.com/office/drawing/2014/main" id="{D2EF6B7E-187A-4662-8B2E-44CB100DB225}"/>
               </a:ext>
             </a:extLst>
           </p:cNvPr>
@@ -8792,7 +10250,7 @@
           <p:cNvPr id="3" name="">
             <a:extLst xmlns:a="http://schemas.openxmlformats.org/drawingml/2006/main">
               <a:ext uri="{FF2B5EF4-FFF2-40B4-BE49-F238E27FC236}">
-                <a16:creationId xmlns:a16="http://schemas.microsoft.com/office/drawing/2014/main" id="{E1BC79E6-35C3-4BED-B55E-9A0386667075}"/>
+                <a16:creationId xmlns:a16="http://schemas.microsoft.com/office/drawing/2014/main" id="{4401507B-29D8-4F66-8CB6-6D8645F7A07E}"/>
               </a:ext>
             </a:extLst>
           </p:cNvPr>
@@ -8849,7 +10307,7 @@
           <p:cNvPr id="4" name="">
             <a:extLst xmlns:a="http://schemas.openxmlformats.org/drawingml/2006/main">
               <a:ext uri="{FF2B5EF4-FFF2-40B4-BE49-F238E27FC236}">
-                <a16:creationId xmlns:a16="http://schemas.microsoft.com/office/drawing/2014/main" id="{EF38C3F2-78AF-46F2-B545-EE8EF56A45E8}"/>
+                <a16:creationId xmlns:a16="http://schemas.microsoft.com/office/drawing/2014/main" id="{A40B645A-F958-4446-8CD3-081B98BA4B62}"/>
               </a:ext>
             </a:extLst>
           </p:cNvPr>
@@ -8935,7 +10393,7 @@
                           <a:ea typeface="Arial"/>
                           <a:cs typeface="Arial"/>
                         </a:rPr>
-                        <a:t>01.06.2025, Москва</a:t>
+                        <a:t>Момент данных, Москва</a:t>
                       </a:r>
                     </a:p>
                   </a:txBody>
@@ -9151,7 +10609,7 @@
           <p:cNvPr id="6" name="">
             <a:extLst xmlns:a="http://schemas.openxmlformats.org/drawingml/2006/main">
               <a:ext uri="{FF2B5EF4-FFF2-40B4-BE49-F238E27FC236}">
-                <a16:creationId xmlns:a16="http://schemas.microsoft.com/office/drawing/2014/main" id="{0518A9BC-A20F-4F61-8594-AE4DE4F15630}"/>
+                <a16:creationId xmlns:a16="http://schemas.microsoft.com/office/drawing/2014/main" id="{1F790C96-04D4-4978-9574-4AB95E5440DB}"/>
               </a:ext>
             </a:extLst>
           </p:cNvPr>
@@ -9208,7 +10666,7 @@
           <p:cNvPr id="7" name="">
             <a:extLst xmlns:a="http://schemas.openxmlformats.org/drawingml/2006/main">
               <a:ext uri="{FF2B5EF4-FFF2-40B4-BE49-F238E27FC236}">
-                <a16:creationId xmlns:a16="http://schemas.microsoft.com/office/drawing/2014/main" id="{43FD65DC-E8C7-497D-9319-2D4963EF3DC1}"/>
+                <a16:creationId xmlns:a16="http://schemas.microsoft.com/office/drawing/2014/main" id="{CA8E0540-8BF0-4817-AEFE-8F1B419B09F5}"/>
               </a:ext>
             </a:extLst>
           </p:cNvPr>
@@ -9255,7 +10713,7 @@
                 <a:ea typeface="Arial"/>
                 <a:cs typeface="Arial"/>
               </a:rPr>
-              <a:t>Интервал: прогресс, отмена, частичный результат и экспорт.</a:t>
+              <a:t>Целевое время на графике: момент данных + 60 минут.</a:t>
             </a:r>
           </a:p>
         </p:txBody>
@@ -9263,7 +10721,7 @@
     </p:spTree>
     <p:extLst>
       <p:ext uri="{BB962C8B-B14F-4D97-AF65-F5344CB8AC3E}">
-        <p14:creationId xmlns:p14="http://schemas.microsoft.com/office/powerpoint/2010/main" val="189170439"/>
+        <p14:creationId xmlns:p14="http://schemas.microsoft.com/office/powerpoint/2010/main" val="2116743389"/>
       </p:ext>
     </p:extLst>
   </p:cSld>
@@ -9294,7 +10752,7 @@
           <p:cNvPr id="8" name="">
             <a:extLst xmlns:a="http://schemas.openxmlformats.org/drawingml/2006/main">
               <a:ext uri="{FF2B5EF4-FFF2-40B4-BE49-F238E27FC236}">
-                <a16:creationId xmlns:a16="http://schemas.microsoft.com/office/drawing/2014/main" id="{92F0106F-D5CB-4617-B7FC-456EAF5A45F4}"/>
+                <a16:creationId xmlns:a16="http://schemas.microsoft.com/office/drawing/2014/main" id="{C90E2827-4470-46E9-B5DE-BD76E8EBDA6F}"/>
               </a:ext>
             </a:extLst>
           </p:cNvPr>
@@ -9351,7 +10809,7 @@
           <p:cNvPr id="2" name="">
             <a:extLst xmlns:a="http://schemas.openxmlformats.org/drawingml/2006/main">
               <a:ext uri="{FF2B5EF4-FFF2-40B4-BE49-F238E27FC236}">
-                <a16:creationId xmlns:a16="http://schemas.microsoft.com/office/drawing/2014/main" id="{B45B973C-7540-4452-A85A-C7E258658534}"/>
+                <a16:creationId xmlns:a16="http://schemas.microsoft.com/office/drawing/2014/main" id="{D3D37282-517E-44AE-92E8-DFC33C19C9BC}"/>
               </a:ext>
             </a:extLst>
           </p:cNvPr>
@@ -9408,7 +10866,7 @@
           <p:cNvPr id="3" name="">
             <a:extLst xmlns:a="http://schemas.openxmlformats.org/drawingml/2006/main">
               <a:ext uri="{FF2B5EF4-FFF2-40B4-BE49-F238E27FC236}">
-                <a16:creationId xmlns:a16="http://schemas.microsoft.com/office/drawing/2014/main" id="{C71EE5AD-523B-4EF6-A379-4ADCDFEF8676}"/>
+                <a16:creationId xmlns:a16="http://schemas.microsoft.com/office/drawing/2014/main" id="{95CC62E9-95E8-4A81-9BCC-C106C5229D4B}"/>
               </a:ext>
             </a:extLst>
           </p:cNvPr>
@@ -9465,7 +10923,7 @@
           <p:cNvPr id="4" name="">
             <a:extLst xmlns:a="http://schemas.openxmlformats.org/drawingml/2006/main">
               <a:ext uri="{FF2B5EF4-FFF2-40B4-BE49-F238E27FC236}">
-                <a16:creationId xmlns:a16="http://schemas.microsoft.com/office/drawing/2014/main" id="{D99335BB-25C0-4C91-AD32-B1E330431CF5}"/>
+                <a16:creationId xmlns:a16="http://schemas.microsoft.com/office/drawing/2014/main" id="{721CD151-2B56-4E40-BFC9-12777FEF7293}"/>
               </a:ext>
             </a:extLst>
           </p:cNvPr>
@@ -9794,7 +11252,7 @@
           <p:cNvPr id="6" name="">
             <a:extLst xmlns:a="http://schemas.openxmlformats.org/drawingml/2006/main">
               <a:ext uri="{FF2B5EF4-FFF2-40B4-BE49-F238E27FC236}">
-                <a16:creationId xmlns:a16="http://schemas.microsoft.com/office/drawing/2014/main" id="{AC2B83CE-6BE0-44FF-82E1-5848F0791389}"/>
+                <a16:creationId xmlns:a16="http://schemas.microsoft.com/office/drawing/2014/main" id="{A7E87381-06A4-43A4-B942-84D67A8B1EAB}"/>
               </a:ext>
             </a:extLst>
           </p:cNvPr>
@@ -9851,7 +11309,7 @@
           <p:cNvPr id="7" name="">
             <a:extLst xmlns:a="http://schemas.openxmlformats.org/drawingml/2006/main">
               <a:ext uri="{FF2B5EF4-FFF2-40B4-BE49-F238E27FC236}">
-                <a16:creationId xmlns:a16="http://schemas.microsoft.com/office/drawing/2014/main" id="{C7F10D3C-2E7F-4D8C-B1CE-8EB39DF83F19}"/>
+                <a16:creationId xmlns:a16="http://schemas.microsoft.com/office/drawing/2014/main" id="{6C0DF534-A536-460C-862D-E1F2CCD5C560}"/>
               </a:ext>
             </a:extLst>
           </p:cNvPr>
@@ -9906,7 +11364,7 @@
     </p:spTree>
     <p:extLst>
       <p:ext uri="{BB962C8B-B14F-4D97-AF65-F5344CB8AC3E}">
-        <p14:creationId xmlns:p14="http://schemas.microsoft.com/office/powerpoint/2010/main" val="819519914"/>
+        <p14:creationId xmlns:p14="http://schemas.microsoft.com/office/powerpoint/2010/main" val="197467227"/>
       </p:ext>
     </p:extLst>
   </p:cSld>

</xml_diff>